<commit_message>
fixed the website and off to the races..
</commit_message>
<xml_diff>
--- a/docs/lectures/lecture_01/01_lecture_powerpoint.pptx
+++ b/docs/lectures/lecture_01/01_lecture_powerpoint.pptx
@@ -12,6 +12,15 @@
     <p:sldId id="260" r:id="rId6"/>
     <p:sldId id="261" r:id="rId7"/>
     <p:sldId id="262" r:id="rId8"/>
+    <p:sldId id="263" r:id="rId9"/>
+    <p:sldId id="264" r:id="rId10"/>
+    <p:sldId id="265" r:id="rId11"/>
+    <p:sldId id="266" r:id="rId12"/>
+    <p:sldId id="267" r:id="rId13"/>
+    <p:sldId id="268" r:id="rId14"/>
+    <p:sldId id="269" r:id="rId15"/>
+    <p:sldId id="270" r:id="rId16"/>
+    <p:sldId id="271" r:id="rId17"/>
   </p:sldIdLst>
   <p:sldSz cx="9144000" cy="5143500" type="screen16x9"/>
   <p:notesSz cx="6858000" cy="9144000"/>
@@ -3339,6 +3348,780 @@
 </p:sld>
 </file>
 
+<file path=ppt/slides/slide10.xml><?xml version="1.0" encoding="utf-8"?>
+<p:sld xmlns:a="http://schemas.openxmlformats.org/drawingml/2006/main" xmlns:r="http://schemas.openxmlformats.org/officeDocument/2006/relationships" xmlns:p="http://schemas.openxmlformats.org/presentationml/2006/main">
+  <p:cSld>
+    <p:spTree>
+      <p:nvGrpSpPr>
+        <p:cNvPr id="1" name=""/>
+        <p:cNvGrpSpPr/>
+        <p:nvPr/>
+      </p:nvGrpSpPr>
+      <p:grpSpPr>
+        <a:xfrm>
+          <a:off x="0" y="0"/>
+          <a:ext cx="0" cy="0"/>
+          <a:chOff x="0" y="0"/>
+          <a:chExt cx="0" cy="0"/>
+        </a:xfrm>
+      </p:grpSpPr>
+      <p:sp>
+        <p:nvSpPr>
+          <p:cNvPr id="2" name="Title 1"/>
+          <p:cNvSpPr>
+            <a:spLocks noGrp="1"/>
+          </p:cNvSpPr>
+          <p:nvPr>
+            <p:ph type="title"/>
+          </p:nvPr>
+        </p:nvSpPr>
+        <p:spPr>
+          <a:xfrm>
+            <a:off x="0" y="0"/>
+            <a:ext cx="9144000" cy="582780"/>
+          </a:xfrm>
+        </p:spPr>
+        <p:txBody>
+          <a:bodyPr/>
+          <a:lstStyle/>
+          <a:p>
+            <a:pPr lvl="0" indent="0" marL="0">
+              <a:buNone/>
+            </a:pPr>
+            <a:r>
+              <a:rPr/>
+              <a:t>How would we collect data to test this?</a:t>
+            </a:r>
+          </a:p>
+        </p:txBody>
+      </p:sp>
+      <p:sp>
+        <p:nvSpPr>
+          <p:cNvPr id="3" name="Content Placeholder 2"/>
+          <p:cNvSpPr>
+            <a:spLocks noGrp="1"/>
+          </p:cNvSpPr>
+          <p:nvPr>
+            <p:ph idx="1"/>
+          </p:nvPr>
+        </p:nvSpPr>
+        <p:spPr/>
+        <p:txBody>
+          <a:bodyPr/>
+          <a:lstStyle/>
+          <a:p>
+            <a:pPr lvl="0"/>
+            <a:r>
+              <a:rPr/>
+              <a:t>Can we collect leaves from one tree to do this?</a:t>
+            </a:r>
+          </a:p>
+          <a:p>
+            <a:pPr lvl="1"/>
+            <a:r>
+              <a:rPr/>
+              <a:t>YES?</a:t>
+            </a:r>
+          </a:p>
+          <a:p>
+            <a:pPr lvl="1"/>
+            <a:r>
+              <a:rPr/>
+              <a:t>NO?</a:t>
+            </a:r>
+          </a:p>
+          <a:p>
+            <a:pPr lvl="1"/>
+            <a:r>
+              <a:rPr/>
+              <a:t>Discuss</a:t>
+            </a:r>
+          </a:p>
+          <a:p>
+            <a:pPr lvl="0"/>
+            <a:r>
+              <a:rPr/>
+              <a:t>What might be the effect if we used only one tree?</a:t>
+            </a:r>
+          </a:p>
+          <a:p>
+            <a:pPr lvl="0"/>
+            <a:r>
+              <a:rPr/>
+              <a:t>How might that differ from many trees?</a:t>
+            </a:r>
+          </a:p>
+          <a:p>
+            <a:pPr lvl="0"/>
+            <a:r>
+              <a:rPr/>
+              <a:t>Do we need to be sure our sample is randomly selected?</a:t>
+            </a:r>
+          </a:p>
+          <a:p>
+            <a:pPr lvl="1"/>
+            <a:r>
+              <a:rPr/>
+              <a:t>why do we need to randomize sampling?</a:t>
+            </a:r>
+          </a:p>
+          <a:p>
+            <a:pPr lvl="1"/>
+            <a:r>
+              <a:rPr/>
+              <a:t>how can we randomize our sampling?</a:t>
+            </a:r>
+          </a:p>
+        </p:txBody>
+      </p:sp>
+    </p:spTree>
+  </p:cSld>
+</p:sld>
+</file>
+
+<file path=ppt/slides/slide11.xml><?xml version="1.0" encoding="utf-8"?>
+<p:sld xmlns:a="http://schemas.openxmlformats.org/drawingml/2006/main" xmlns:r="http://schemas.openxmlformats.org/officeDocument/2006/relationships" xmlns:p="http://schemas.openxmlformats.org/presentationml/2006/main">
+  <p:cSld>
+    <p:spTree>
+      <p:nvGrpSpPr>
+        <p:cNvPr id="1" name=""/>
+        <p:cNvGrpSpPr/>
+        <p:nvPr/>
+      </p:nvGrpSpPr>
+      <p:grpSpPr>
+        <a:xfrm>
+          <a:off x="0" y="0"/>
+          <a:ext cx="0" cy="0"/>
+          <a:chOff x="0" y="0"/>
+          <a:chExt cx="0" cy="0"/>
+        </a:xfrm>
+      </p:grpSpPr>
+      <p:sp>
+        <p:nvSpPr>
+          <p:cNvPr id="2" name="Title 1"/>
+          <p:cNvSpPr>
+            <a:spLocks noGrp="1"/>
+          </p:cNvSpPr>
+          <p:nvPr>
+            <p:ph type="title"/>
+          </p:nvPr>
+        </p:nvSpPr>
+        <p:spPr>
+          <a:xfrm>
+            <a:off x="0" y="0"/>
+            <a:ext cx="9144000" cy="582780"/>
+          </a:xfrm>
+        </p:spPr>
+        <p:txBody>
+          <a:bodyPr/>
+          <a:lstStyle/>
+          <a:p>
+            <a:pPr lvl="0" indent="0" marL="0">
+              <a:buNone/>
+            </a:pPr>
+            <a:r>
+              <a:rPr/>
+              <a:t>What are the different variables we could record?</a:t>
+            </a:r>
+          </a:p>
+        </p:txBody>
+      </p:sp>
+      <p:sp>
+        <p:nvSpPr>
+          <p:cNvPr id="3" name="Content Placeholder 2"/>
+          <p:cNvSpPr>
+            <a:spLocks noGrp="1"/>
+          </p:cNvSpPr>
+          <p:nvPr>
+            <p:ph idx="1"/>
+          </p:nvPr>
+        </p:nvSpPr>
+        <p:spPr/>
+        <p:txBody>
+          <a:bodyPr/>
+          <a:lstStyle/>
+          <a:p>
+            <a:pPr lvl="0"/>
+            <a:r>
+              <a:rPr/>
+              <a:t>What variables could we record about the tree?</a:t>
+            </a:r>
+          </a:p>
+          <a:p>
+            <a:pPr lvl="0"/>
+            <a:r>
+              <a:rPr/>
+              <a:t>What variables could we record about the leaf?</a:t>
+            </a:r>
+          </a:p>
+          <a:p>
+            <a:pPr lvl="1"/>
+            <a:r>
+              <a:rPr/>
+              <a:t>what is a dependent variable?</a:t>
+            </a:r>
+          </a:p>
+          <a:p>
+            <a:pPr lvl="2"/>
+            <a:r>
+              <a:rPr/>
+              <a:t>[class discussion here]</a:t>
+            </a:r>
+          </a:p>
+          <a:p>
+            <a:pPr lvl="1"/>
+            <a:r>
+              <a:rPr/>
+              <a:t>what is an independent variable?</a:t>
+            </a:r>
+          </a:p>
+          <a:p>
+            <a:pPr lvl="2"/>
+            <a:r>
+              <a:rPr/>
+              <a:t>[class discussion here]</a:t>
+            </a:r>
+          </a:p>
+        </p:txBody>
+      </p:sp>
+    </p:spTree>
+  </p:cSld>
+</p:sld>
+</file>
+
+<file path=ppt/slides/slide12.xml><?xml version="1.0" encoding="utf-8"?>
+<p:sld xmlns:a="http://schemas.openxmlformats.org/drawingml/2006/main" xmlns:r="http://schemas.openxmlformats.org/officeDocument/2006/relationships" xmlns:p="http://schemas.openxmlformats.org/presentationml/2006/main">
+  <p:cSld>
+    <p:spTree>
+      <p:nvGrpSpPr>
+        <p:cNvPr id="1" name=""/>
+        <p:cNvGrpSpPr/>
+        <p:nvPr/>
+      </p:nvGrpSpPr>
+      <p:grpSpPr>
+        <a:xfrm>
+          <a:off x="0" y="0"/>
+          <a:ext cx="0" cy="0"/>
+          <a:chOff x="0" y="0"/>
+          <a:chExt cx="0" cy="0"/>
+        </a:xfrm>
+      </p:grpSpPr>
+      <p:sp>
+        <p:nvSpPr>
+          <p:cNvPr id="2" name="Title 1"/>
+          <p:cNvSpPr>
+            <a:spLocks noGrp="1"/>
+          </p:cNvSpPr>
+          <p:nvPr>
+            <p:ph type="title"/>
+          </p:nvPr>
+        </p:nvSpPr>
+        <p:spPr>
+          <a:xfrm>
+            <a:off x="0" y="0"/>
+            <a:ext cx="9144000" cy="582780"/>
+          </a:xfrm>
+        </p:spPr>
+        <p:txBody>
+          <a:bodyPr/>
+          <a:lstStyle/>
+          <a:p>
+            <a:pPr lvl="0" indent="0" marL="0">
+              <a:buNone/>
+            </a:pPr>
+            <a:r>
+              <a:rPr/>
+              <a:t>Each group needs to collect at least 3 pairs of leaves</a:t>
+            </a:r>
+          </a:p>
+        </p:txBody>
+      </p:sp>
+      <p:sp>
+        <p:nvSpPr>
+          <p:cNvPr id="3" name="Content Placeholder 2"/>
+          <p:cNvSpPr>
+            <a:spLocks noGrp="1"/>
+          </p:cNvSpPr>
+          <p:nvPr>
+            <p:ph idx="1"/>
+          </p:nvPr>
+        </p:nvSpPr>
+        <p:spPr/>
+        <p:txBody>
+          <a:bodyPr/>
+          <a:lstStyle/>
+          <a:p>
+            <a:pPr lvl="0"/>
+            <a:r>
+              <a:rPr/>
+              <a:t>How can we standardize our collections?</a:t>
+            </a:r>
+          </a:p>
+          <a:p>
+            <a:pPr lvl="1"/>
+            <a:r>
+              <a:rPr/>
+              <a:t>A mature leaf from the sunny side and 1 leaf from the shady side?</a:t>
+            </a:r>
+          </a:p>
+          <a:p>
+            <a:pPr lvl="1"/>
+            <a:r>
+              <a:rPr/>
+              <a:t>Do this on 2 separate trees - and for this we can use the trees others use as we are limited</a:t>
+            </a:r>
+          </a:p>
+          <a:p>
+            <a:pPr lvl="0"/>
+            <a:r>
+              <a:rPr/>
+              <a:t>How high do we collect?</a:t>
+            </a:r>
+          </a:p>
+          <a:p>
+            <a:pPr lvl="0"/>
+            <a:r>
+              <a:rPr/>
+              <a:t>Are there other things to do?</a:t>
+            </a:r>
+          </a:p>
+        </p:txBody>
+      </p:sp>
+    </p:spTree>
+  </p:cSld>
+</p:sld>
+</file>
+
+<file path=ppt/slides/slide13.xml><?xml version="1.0" encoding="utf-8"?>
+<p:sld xmlns:a="http://schemas.openxmlformats.org/drawingml/2006/main" xmlns:r="http://schemas.openxmlformats.org/officeDocument/2006/relationships" xmlns:p="http://schemas.openxmlformats.org/presentationml/2006/main">
+  <p:cSld>
+    <p:spTree>
+      <p:nvGrpSpPr>
+        <p:cNvPr id="1" name=""/>
+        <p:cNvGrpSpPr/>
+        <p:nvPr/>
+      </p:nvGrpSpPr>
+      <p:grpSpPr>
+        <a:xfrm>
+          <a:off x="0" y="0"/>
+          <a:ext cx="0" cy="0"/>
+          <a:chOff x="0" y="0"/>
+          <a:chExt cx="0" cy="0"/>
+        </a:xfrm>
+      </p:grpSpPr>
+      <p:sp>
+        <p:nvSpPr>
+          <p:cNvPr id="2" name="Title 1"/>
+          <p:cNvSpPr>
+            <a:spLocks noGrp="1"/>
+          </p:cNvSpPr>
+          <p:nvPr>
+            <p:ph type="title"/>
+          </p:nvPr>
+        </p:nvSpPr>
+        <p:spPr>
+          <a:xfrm>
+            <a:off x="0" y="0"/>
+            <a:ext cx="9144000" cy="582780"/>
+          </a:xfrm>
+        </p:spPr>
+        <p:txBody>
+          <a:bodyPr/>
+          <a:lstStyle/>
+          <a:p>
+            <a:pPr lvl="0" indent="0" marL="0">
+              <a:buNone/>
+            </a:pPr>
+            <a:r>
+              <a:rPr/>
+              <a:t>Back in the laboratory - before we even begin</a:t>
+            </a:r>
+          </a:p>
+        </p:txBody>
+      </p:sp>
+      <p:sp>
+        <p:nvSpPr>
+          <p:cNvPr id="3" name="Content Placeholder 2"/>
+          <p:cNvSpPr>
+            <a:spLocks noGrp="1"/>
+          </p:cNvSpPr>
+          <p:nvPr>
+            <p:ph idx="1"/>
+          </p:nvPr>
+        </p:nvSpPr>
+        <p:spPr/>
+        <p:txBody>
+          <a:bodyPr/>
+          <a:lstStyle/>
+          <a:p>
+            <a:pPr lvl="0"/>
+            <a:r>
+              <a:rPr/>
+              <a:t>What are the steps we need to decide on when processing this data?</a:t>
+            </a:r>
+          </a:p>
+          <a:p>
+            <a:pPr lvl="0"/>
+            <a:r>
+              <a:rPr/>
+              <a:t>What can we measure?</a:t>
+            </a:r>
+          </a:p>
+          <a:p>
+            <a:pPr lvl="1"/>
+            <a:r>
+              <a:rPr/>
+              <a:t>mass?</a:t>
+            </a:r>
+          </a:p>
+          <a:p>
+            <a:pPr lvl="1"/>
+            <a:r>
+              <a:rPr/>
+              <a:t>length?</a:t>
+            </a:r>
+          </a:p>
+          <a:p>
+            <a:pPr lvl="1"/>
+            <a:r>
+              <a:rPr/>
+              <a:t>width?</a:t>
+            </a:r>
+          </a:p>
+          <a:p>
+            <a:pPr lvl="1"/>
+            <a:r>
+              <a:rPr/>
+              <a:t>surface area?</a:t>
+            </a:r>
+          </a:p>
+          <a:p>
+            <a:pPr lvl="1"/>
+            <a:r>
+              <a:rPr/>
+              <a:t>others?</a:t>
+            </a:r>
+          </a:p>
+        </p:txBody>
+      </p:sp>
+    </p:spTree>
+  </p:cSld>
+</p:sld>
+</file>
+
+<file path=ppt/slides/slide14.xml><?xml version="1.0" encoding="utf-8"?>
+<p:sld xmlns:a="http://schemas.openxmlformats.org/drawingml/2006/main" xmlns:r="http://schemas.openxmlformats.org/officeDocument/2006/relationships" xmlns:p="http://schemas.openxmlformats.org/presentationml/2006/main">
+  <p:cSld>
+    <p:spTree>
+      <p:nvGrpSpPr>
+        <p:cNvPr id="1" name=""/>
+        <p:cNvGrpSpPr/>
+        <p:nvPr/>
+      </p:nvGrpSpPr>
+      <p:grpSpPr>
+        <a:xfrm>
+          <a:off x="0" y="0"/>
+          <a:ext cx="0" cy="0"/>
+          <a:chOff x="0" y="0"/>
+          <a:chExt cx="0" cy="0"/>
+        </a:xfrm>
+      </p:grpSpPr>
+      <p:sp>
+        <p:nvSpPr>
+          <p:cNvPr id="2" name="Title 1"/>
+          <p:cNvSpPr>
+            <a:spLocks noGrp="1"/>
+          </p:cNvSpPr>
+          <p:nvPr>
+            <p:ph type="title"/>
+          </p:nvPr>
+        </p:nvSpPr>
+        <p:spPr>
+          <a:xfrm>
+            <a:off x="0" y="0"/>
+            <a:ext cx="9144000" cy="582780"/>
+          </a:xfrm>
+        </p:spPr>
+        <p:txBody>
+          <a:bodyPr/>
+          <a:lstStyle/>
+          <a:p>
+            <a:pPr lvl="0" indent="0" marL="0">
+              <a:buNone/>
+            </a:pPr>
+            <a:r>
+              <a:rPr/>
+              <a:t>Back in the laboratory - before we even begin</a:t>
+            </a:r>
+          </a:p>
+        </p:txBody>
+      </p:sp>
+      <p:sp>
+        <p:nvSpPr>
+          <p:cNvPr id="3" name="Content Placeholder 2"/>
+          <p:cNvSpPr>
+            <a:spLocks noGrp="1"/>
+          </p:cNvSpPr>
+          <p:nvPr>
+            <p:ph idx="1"/>
+          </p:nvPr>
+        </p:nvSpPr>
+        <p:spPr/>
+        <p:txBody>
+          <a:bodyPr/>
+          <a:lstStyle/>
+          <a:p>
+            <a:pPr lvl="0"/>
+            <a:r>
+              <a:rPr/>
+              <a:t>How do you enter this into the excel sheet</a:t>
+            </a:r>
+          </a:p>
+          <a:p>
+            <a:pPr lvl="1"/>
+            <a:r>
+              <a:rPr/>
+              <a:t>what does the sheet look like - mock up something to show the rest of the class?</a:t>
+            </a:r>
+          </a:p>
+          <a:p>
+            <a:pPr lvl="0"/>
+            <a:r>
+              <a:rPr/>
+              <a:t>What are the terms you will use?</a:t>
+            </a:r>
+          </a:p>
+          <a:p>
+            <a:pPr lvl="0"/>
+            <a:r>
+              <a:rPr/>
+              <a:t>What are the units?</a:t>
+            </a:r>
+          </a:p>
+          <a:p>
+            <a:pPr lvl="0"/>
+            <a:r>
+              <a:rPr/>
+              <a:t>What is meta data?</a:t>
+            </a:r>
+          </a:p>
+          <a:p>
+            <a:pPr lvl="0"/>
+            <a:r>
+              <a:rPr/>
+              <a:t>What vocabulary do you use?</a:t>
+            </a:r>
+          </a:p>
+        </p:txBody>
+      </p:sp>
+    </p:spTree>
+  </p:cSld>
+</p:sld>
+</file>
+
+<file path=ppt/slides/slide15.xml><?xml version="1.0" encoding="utf-8"?>
+<p:sld xmlns:a="http://schemas.openxmlformats.org/drawingml/2006/main" xmlns:r="http://schemas.openxmlformats.org/officeDocument/2006/relationships" xmlns:p="http://schemas.openxmlformats.org/presentationml/2006/main">
+  <p:cSld>
+    <p:spTree>
+      <p:nvGrpSpPr>
+        <p:cNvPr id="1" name=""/>
+        <p:cNvGrpSpPr/>
+        <p:nvPr/>
+      </p:nvGrpSpPr>
+      <p:grpSpPr>
+        <a:xfrm>
+          <a:off x="0" y="0"/>
+          <a:ext cx="0" cy="0"/>
+          <a:chOff x="0" y="0"/>
+          <a:chExt cx="0" cy="0"/>
+        </a:xfrm>
+      </p:grpSpPr>
+      <p:sp>
+        <p:nvSpPr>
+          <p:cNvPr id="2" name="Title 1"/>
+          <p:cNvSpPr>
+            <a:spLocks noGrp="1"/>
+          </p:cNvSpPr>
+          <p:nvPr>
+            <p:ph type="title"/>
+          </p:nvPr>
+        </p:nvSpPr>
+        <p:spPr>
+          <a:xfrm>
+            <a:off x="0" y="0"/>
+            <a:ext cx="9144000" cy="582780"/>
+          </a:xfrm>
+        </p:spPr>
+        <p:txBody>
+          <a:bodyPr/>
+          <a:lstStyle/>
+          <a:p>
+            <a:pPr lvl="0" indent="0" marL="0">
+              <a:buNone/>
+            </a:pPr>
+            <a:r>
+              <a:rPr/>
+              <a:t>Can you make a graph of the data in Excel based on what we collected?</a:t>
+            </a:r>
+          </a:p>
+        </p:txBody>
+      </p:sp>
+      <p:sp>
+        <p:nvSpPr>
+          <p:cNvPr id="3" name="Content Placeholder 2"/>
+          <p:cNvSpPr>
+            <a:spLocks noGrp="1"/>
+          </p:cNvSpPr>
+          <p:nvPr>
+            <p:ph idx="1"/>
+          </p:nvPr>
+        </p:nvSpPr>
+        <p:spPr/>
+        <p:txBody>
+          <a:bodyPr/>
+          <a:lstStyle/>
+          <a:p>
+            <a:pPr lvl="0"/>
+            <a:r>
+              <a:rPr/>
+              <a:t>what would the graph look like?</a:t>
+            </a:r>
+          </a:p>
+          <a:p>
+            <a:pPr lvl="0"/>
+            <a:r>
+              <a:rPr/>
+              <a:t>what can you derive from the data?</a:t>
+            </a:r>
+          </a:p>
+        </p:txBody>
+      </p:sp>
+    </p:spTree>
+  </p:cSld>
+</p:sld>
+</file>
+
+<file path=ppt/slides/slide16.xml><?xml version="1.0" encoding="utf-8"?>
+<p:sld xmlns:a="http://schemas.openxmlformats.org/drawingml/2006/main" xmlns:r="http://schemas.openxmlformats.org/officeDocument/2006/relationships" xmlns:p="http://schemas.openxmlformats.org/presentationml/2006/main">
+  <p:cSld>
+    <p:spTree>
+      <p:nvGrpSpPr>
+        <p:cNvPr id="1" name=""/>
+        <p:cNvGrpSpPr/>
+        <p:nvPr/>
+      </p:nvGrpSpPr>
+      <p:grpSpPr>
+        <a:xfrm>
+          <a:off x="0" y="0"/>
+          <a:ext cx="0" cy="0"/>
+          <a:chOff x="0" y="0"/>
+          <a:chExt cx="0" cy="0"/>
+        </a:xfrm>
+      </p:grpSpPr>
+      <p:sp>
+        <p:nvSpPr>
+          <p:cNvPr id="2" name="Title 1"/>
+          <p:cNvSpPr>
+            <a:spLocks noGrp="1"/>
+          </p:cNvSpPr>
+          <p:nvPr>
+            <p:ph type="title"/>
+          </p:nvPr>
+        </p:nvSpPr>
+        <p:spPr>
+          <a:xfrm>
+            <a:off x="0" y="0"/>
+            <a:ext cx="9144000" cy="582780"/>
+          </a:xfrm>
+        </p:spPr>
+        <p:txBody>
+          <a:bodyPr/>
+          <a:lstStyle/>
+          <a:p>
+            <a:pPr lvl="0" indent="0" marL="0">
+              <a:buNone/>
+            </a:pPr>
+            <a:r>
+              <a:rPr/>
+              <a:t>Before Thursday Install R and Positron</a:t>
+            </a:r>
+          </a:p>
+        </p:txBody>
+      </p:sp>
+      <p:sp>
+        <p:nvSpPr>
+          <p:cNvPr id="3" name="Content Placeholder 2"/>
+          <p:cNvSpPr>
+            <a:spLocks noGrp="1"/>
+          </p:cNvSpPr>
+          <p:nvPr>
+            <p:ph idx="1"/>
+          </p:nvPr>
+        </p:nvSpPr>
+        <p:spPr/>
+        <p:txBody>
+          <a:bodyPr/>
+          <a:lstStyle/>
+          <a:p>
+            <a:pPr lvl="0" indent="0" marL="0">
+              <a:buNone/>
+            </a:pPr>
+            <a:r>
+              <a:rPr/>
+              <a:t>Downloading R and Positron:</a:t>
+            </a:r>
+          </a:p>
+          <a:p>
+            <a:pPr lvl="0" indent="-342900" marL="342900">
+              <a:buAutoNum type="arabicPeriod"/>
+            </a:pPr>
+            <a:r>
+              <a:rPr/>
+              <a:t>Download R - </a:t>
+            </a:r>
+            <a:r>
+              <a:rPr>
+                <a:hlinkClick r:id="rId2"/>
+              </a:rPr>
+              <a:t>download here</a:t>
+            </a:r>
+          </a:p>
+          <a:p>
+            <a:pPr lvl="1"/>
+            <a:r>
+              <a:rPr/>
+              <a:t>downloads to your computer - can you find it?</a:t>
+            </a:r>
+          </a:p>
+          <a:p>
+            <a:pPr lvl="0" indent="-342900" marL="342900">
+              <a:buAutoNum type="arabicPeriod"/>
+            </a:pPr>
+            <a:r>
+              <a:rPr/>
+              <a:t>Download Positron - </a:t>
+            </a:r>
+            <a:r>
+              <a:rPr>
+                <a:hlinkClick r:id="rId3"/>
+              </a:rPr>
+              <a:t>download here</a:t>
+            </a:r>
+          </a:p>
+          <a:p>
+            <a:pPr lvl="1"/>
+            <a:r>
+              <a:rPr/>
+              <a:t>downloads to your computer - can you find it?</a:t>
+            </a:r>
+          </a:p>
+        </p:txBody>
+      </p:sp>
+    </p:spTree>
+  </p:cSld>
+</p:sld>
+</file>
+
 <file path=ppt/slides/slide2.xml><?xml version="1.0" encoding="utf-8"?>
 <p:sld xmlns:a="http://schemas.openxmlformats.org/drawingml/2006/main" xmlns:r="http://schemas.openxmlformats.org/officeDocument/2006/relationships" xmlns:p="http://schemas.openxmlformats.org/presentationml/2006/main">
   <p:cSld>
@@ -3404,7 +4187,7 @@
             <a:pPr lvl="0"/>
             <a:r>
               <a:rPr/>
-              <a:t>Please look over the syllabus as it has all the details of the class and how it will run.</a:t>
+              <a:t>Please look over the syllabus as it has all the details of the class and how it will run. It will serve as the tentative list of topics and what we will cover each day</a:t>
             </a:r>
           </a:p>
         </p:txBody>
@@ -3444,8 +4227,11 @@
         <p:spPr>
           <a:xfrm>
             <a:off x="0" y="0"/>
-            <a:ext cx="9144000" cy="582780"/>
+            <a:ext cx="9144000" cy="602780"/>
           </a:xfrm>
+          <a:solidFill>
+            <a:srgbClr val="70121D"/>
+          </a:solidFill>
         </p:spPr>
         <p:txBody>
           <a:bodyPr/>
@@ -3472,7 +4258,7 @@
             <a:spLocks noGrp="1"/>
           </p:cNvSpPr>
           <p:nvPr>
-            <p:ph idx="1"/>
+            <p:ph idx="1" sz="half"/>
           </p:nvPr>
         </p:nvSpPr>
         <p:spPr/>
@@ -3480,10 +4266,30 @@
           <a:bodyPr/>
           <a:lstStyle/>
           <a:p>
-            <a:pPr lvl="0"/>
-            <a:r>
-              <a:rPr/>
-              <a:t>Bill Perry</a:t>
+            <a:pPr lvl="0" indent="0" marL="0">
+              <a:spcBef>
+                <a:spcPts val="3000"/>
+              </a:spcBef>
+              <a:buNone/>
+            </a:pPr>
+            <a:r>
+              <a:rPr b="1"/>
+              <a:t>The objectives:</a:t>
+            </a:r>
+          </a:p>
+          <a:p>
+            <a:pPr lvl="0"/>
+            <a:r>
+              <a:rPr/>
+              <a:t>Bill Perry - </a:t>
+            </a:r>
+            <a:r>
+              <a:rPr b="1"/>
+              <a:t>Bill</a:t>
+            </a:r>
+            <a:r>
+              <a:rPr/>
+              <a:t> or Dr. Perry</a:t>
             </a:r>
           </a:p>
           <a:p>
@@ -3504,16 +4310,41 @@
             <a:pPr lvl="0"/>
             <a:r>
               <a:rPr/>
-              <a:t>Email is wlperry_at_d.umn.edu</a:t>
-            </a:r>
-          </a:p>
-          <a:p>
-            <a:pPr lvl="0" indent="0" marL="0">
-              <a:buNone/>
-            </a:pPr>
-          </a:p>
-        </p:txBody>
-      </p:sp>
+              <a:t>Email is wlperry@d.umn.edu</a:t>
+            </a:r>
+          </a:p>
+        </p:txBody>
+      </p:sp>
+      <p:pic>
+        <p:nvPicPr>
+          <p:cNvPr descr="images/paste-1.png" id="0" name="Picture 1"/>
+          <p:cNvPicPr>
+            <a:picLocks noGrp="1" noChangeAspect="1"/>
+          </p:cNvPicPr>
+          <p:nvPr/>
+        </p:nvPicPr>
+        <p:blipFill>
+          <a:blip r:embed="rId2"/>
+          <a:stretch>
+            <a:fillRect/>
+          </a:stretch>
+        </p:blipFill>
+        <p:spPr bwMode="auto">
+          <a:xfrm>
+            <a:off x="6121400" y="1866900"/>
+            <a:ext cx="2781300" cy="2070100"/>
+          </a:xfrm>
+          <a:prstGeom prst="rect">
+            <a:avLst/>
+          </a:prstGeom>
+          <a:noFill/>
+          <a:ln w="9525">
+            <a:noFill/>
+            <a:headEnd/>
+            <a:tailEnd/>
+          </a:ln>
+        </p:spPr>
+      </p:pic>
     </p:spTree>
   </p:cSld>
 </p:sld>
@@ -3584,28 +4415,35 @@
             <a:pPr lvl="0"/>
             <a:r>
               <a:rPr/>
-              <a:t>How do we make observations and hypotheses?</a:t>
-            </a:r>
-          </a:p>
-          <a:p>
-            <a:pPr lvl="0"/>
-            <a:r>
-              <a:rPr/>
-              <a:t>How do we design an experiment</a:t>
-            </a:r>
-          </a:p>
-          <a:p>
-            <a:pPr lvl="0"/>
-            <a:r>
-              <a:rPr/>
-              <a:t>How do we collect data?</a:t>
-            </a:r>
-          </a:p>
-          <a:p>
-            <a:pPr lvl="0"/>
-            <a:r>
-              <a:rPr/>
-              <a:t>How do we organize, clean, summarize, and view the data?</a:t>
+              <a:t>Help you learn the tools to organize and present data from potentially very large data sets</a:t>
+            </a:r>
+          </a:p>
+          <a:p>
+            <a:pPr lvl="0"/>
+            <a:r>
+              <a:rPr/>
+              <a:t>How to use basic excel for some tasks</a:t>
+            </a:r>
+          </a:p>
+          <a:p>
+            <a:pPr lvl="0"/>
+            <a:r>
+              <a:rPr/>
+              <a:t>How to use R - a coding language - to work with data and graphics</a:t>
+            </a:r>
+          </a:p>
+          <a:p>
+            <a:pPr lvl="0"/>
+            <a:r>
+              <a:rPr/>
+              <a:t>How do we organize, clean, summarize, and view the data? The pipeline…</a:t>
+            </a:r>
+          </a:p>
+          <a:p>
+            <a:pPr lvl="0"/>
+            <a:r>
+              <a:rPr/>
+              <a:t>How to formulate hypotheses</a:t>
             </a:r>
           </a:p>
           <a:p>
@@ -3616,24 +4454,10 @@
             </a:r>
           </a:p>
           <a:p>
-            <a:pPr lvl="1"/>
-            <a:r>
-              <a:rPr/>
-              <a:t>what tests to use</a:t>
-            </a:r>
-          </a:p>
-          <a:p>
-            <a:pPr lvl="1"/>
-            <a:r>
-              <a:rPr/>
-              <a:t>what are the assumptions</a:t>
-            </a:r>
-          </a:p>
-          <a:p>
-            <a:pPr lvl="1"/>
-            <a:r>
-              <a:rPr/>
-              <a:t>what are the interpretations</a:t>
+            <a:pPr lvl="0"/>
+            <a:r>
+              <a:rPr/>
+              <a:t>How to interpret what the data is telling us using statistics</a:t>
             </a:r>
           </a:p>
         </p:txBody>
@@ -3707,28 +4531,28 @@
           <a:p>
             <a:pPr lvl="0"/>
             <a:r>
-              <a:rPr/>
+              <a:rPr b="1"/>
               <a:t>Communication</a:t>
             </a:r>
           </a:p>
           <a:p>
             <a:pPr lvl="0"/>
             <a:r>
-              <a:rPr/>
+              <a:rPr b="1"/>
               <a:t>Practice</a:t>
             </a:r>
           </a:p>
           <a:p>
             <a:pPr lvl="0"/>
             <a:r>
-              <a:rPr/>
+              <a:rPr b="1"/>
               <a:t>Failure</a:t>
             </a:r>
           </a:p>
           <a:p>
             <a:pPr lvl="0"/>
             <a:r>
-              <a:rPr/>
+              <a:rPr b="1"/>
               <a:t>Learn to correct and troubleshoot</a:t>
             </a:r>
           </a:p>
@@ -3858,11 +4682,8 @@
         <p:spPr>
           <a:xfrm>
             <a:off x="0" y="0"/>
-            <a:ext cx="9144000" cy="602780"/>
+            <a:ext cx="9144000" cy="582780"/>
           </a:xfrm>
-          <a:solidFill>
-            <a:srgbClr val="70121D"/>
-          </a:solidFill>
         </p:spPr>
         <p:txBody>
           <a:bodyPr/>
@@ -3873,7 +4694,7 @@
             </a:pPr>
             <a:r>
               <a:rPr/>
-              <a:t>What is Statistics?</a:t>
+              <a:t>Today… real world data science</a:t>
             </a:r>
           </a:p>
         </p:txBody>
@@ -3885,7 +4706,7 @@
             <a:spLocks noGrp="1"/>
           </p:cNvSpPr>
           <p:nvPr>
-            <p:ph idx="1" sz="half"/>
+            <p:ph idx="1"/>
           </p:nvPr>
         </p:nvSpPr>
         <p:spPr/>
@@ -3893,24 +4714,106 @@
           <a:bodyPr/>
           <a:lstStyle/>
           <a:p>
+            <a:pPr lvl="0"/>
+            <a:r>
+              <a:rPr/>
+              <a:t>talking about data science is </a:t>
+            </a:r>
+            <a:r>
+              <a:rPr b="1"/>
+              <a:t>SUPER BORING</a:t>
+            </a:r>
+          </a:p>
+          <a:p>
+            <a:pPr lvl="1"/>
+            <a:r>
+              <a:rPr/>
+              <a:t>How do you tell a story with data using math - statistics - code</a:t>
+            </a:r>
+          </a:p>
+          <a:p>
+            <a:pPr lvl="0"/>
+            <a:r>
+              <a:rPr/>
+              <a:t>This lecture and the next will be about how to work with data from the start</a:t>
+            </a:r>
+          </a:p>
+          <a:p>
+            <a:pPr lvl="0"/>
+            <a:r>
+              <a:rPr/>
+              <a:t>Your task will be to collect data - organize it - get it into a spreadsheet</a:t>
+            </a:r>
+          </a:p>
+          <a:p>
+            <a:pPr lvl="0"/>
+            <a:r>
+              <a:rPr/>
+              <a:t>Develop meta data</a:t>
+            </a:r>
+          </a:p>
+        </p:txBody>
+      </p:sp>
+    </p:spTree>
+  </p:cSld>
+</p:sld>
+</file>
+
+<file path=ppt/slides/slide8.xml><?xml version="1.0" encoding="utf-8"?>
+<p:sld xmlns:a="http://schemas.openxmlformats.org/drawingml/2006/main" xmlns:r="http://schemas.openxmlformats.org/officeDocument/2006/relationships" xmlns:p="http://schemas.openxmlformats.org/presentationml/2006/main">
+  <p:cSld>
+    <p:spTree>
+      <p:nvGrpSpPr>
+        <p:cNvPr id="1" name=""/>
+        <p:cNvGrpSpPr/>
+        <p:nvPr/>
+      </p:nvGrpSpPr>
+      <p:grpSpPr>
+        <a:xfrm>
+          <a:off x="0" y="0"/>
+          <a:ext cx="0" cy="0"/>
+          <a:chOff x="0" y="0"/>
+          <a:chExt cx="0" cy="0"/>
+        </a:xfrm>
+      </p:grpSpPr>
+      <p:sp>
+        <p:nvSpPr>
+          <p:cNvPr id="2" name="Title 1"/>
+          <p:cNvSpPr>
+            <a:spLocks noGrp="1"/>
+          </p:cNvSpPr>
+          <p:nvPr>
+            <p:ph type="title"/>
+          </p:nvPr>
+        </p:nvSpPr>
+        <p:spPr>
+          <a:xfrm>
+            <a:off x="0" y="0"/>
+            <a:ext cx="9144000" cy="582780"/>
+          </a:xfrm>
+        </p:spPr>
+        <p:txBody>
+          <a:bodyPr/>
+          <a:lstStyle/>
+          <a:p>
             <a:pPr lvl="0" indent="0" marL="0">
               <a:buNone/>
             </a:pPr>
             <a:r>
               <a:rPr/>
-              <a:t>Zar (1999) - “analysis and interpretation of data with view towards objective evaluation of conclusions based on the data”</a:t>
-            </a:r>
-          </a:p>
-        </p:txBody>
-      </p:sp>
-      <p:sp>
-        <p:nvSpPr>
-          <p:cNvPr id="4" name="Content Placeholder 3"/>
-          <p:cNvSpPr>
-            <a:spLocks noGrp="1"/>
-          </p:cNvSpPr>
-          <p:nvPr>
-            <p:ph idx="2" sz="half"/>
+              <a:t>What will we do</a:t>
+            </a:r>
+          </a:p>
+        </p:txBody>
+      </p:sp>
+      <p:sp>
+        <p:nvSpPr>
+          <p:cNvPr id="3" name="Content Placeholder 2"/>
+          <p:cNvSpPr>
+            <a:spLocks noGrp="1"/>
+          </p:cNvSpPr>
+          <p:nvPr>
+            <p:ph idx="1"/>
           </p:nvPr>
         </p:nvSpPr>
         <p:spPr/>
@@ -3918,12 +4821,134 @@
           <a:bodyPr/>
           <a:lstStyle/>
           <a:p>
+            <a:pPr lvl="0"/>
+            <a:r>
+              <a:rPr/>
+              <a:t>We are going to measure something</a:t>
+            </a:r>
+          </a:p>
+          <a:p>
+            <a:pPr lvl="0"/>
+            <a:r>
+              <a:rPr/>
+              <a:t>My suggestion is leaf mass and surface area from a tree on the sunny side versus shady side?</a:t>
+            </a:r>
+          </a:p>
+          <a:p>
+            <a:pPr lvl="1"/>
+            <a:r>
+              <a:rPr/>
+              <a:t>Do leaves respond to light intensity?</a:t>
+            </a:r>
+          </a:p>
+          <a:p>
+            <a:pPr lvl="1"/>
+            <a:r>
+              <a:rPr/>
+              <a:t>What is the Null Hypothesis</a:t>
+            </a:r>
+          </a:p>
+          <a:p>
+            <a:pPr lvl="1"/>
+            <a:r>
+              <a:rPr/>
+              <a:t>What is the Alternate Hypothesis</a:t>
+            </a:r>
+          </a:p>
+        </p:txBody>
+      </p:sp>
+    </p:spTree>
+  </p:cSld>
+</p:sld>
+</file>
+
+<file path=ppt/slides/slide9.xml><?xml version="1.0" encoding="utf-8"?>
+<p:sld xmlns:a="http://schemas.openxmlformats.org/drawingml/2006/main" xmlns:r="http://schemas.openxmlformats.org/officeDocument/2006/relationships" xmlns:p="http://schemas.openxmlformats.org/presentationml/2006/main">
+  <p:cSld>
+    <p:spTree>
+      <p:nvGrpSpPr>
+        <p:cNvPr id="1" name=""/>
+        <p:cNvGrpSpPr/>
+        <p:nvPr/>
+      </p:nvGrpSpPr>
+      <p:grpSpPr>
+        <a:xfrm>
+          <a:off x="0" y="0"/>
+          <a:ext cx="0" cy="0"/>
+          <a:chOff x="0" y="0"/>
+          <a:chExt cx="0" cy="0"/>
+        </a:xfrm>
+      </p:grpSpPr>
+      <p:sp>
+        <p:nvSpPr>
+          <p:cNvPr id="2" name="Title 1"/>
+          <p:cNvSpPr>
+            <a:spLocks noGrp="1"/>
+          </p:cNvSpPr>
+          <p:nvPr>
+            <p:ph type="title"/>
+          </p:nvPr>
+        </p:nvSpPr>
+        <p:spPr>
+          <a:xfrm>
+            <a:off x="0" y="0"/>
+            <a:ext cx="9144000" cy="582780"/>
+          </a:xfrm>
+        </p:spPr>
+        <p:txBody>
+          <a:bodyPr/>
+          <a:lstStyle/>
+          <a:p>
             <a:pPr lvl="0" indent="0" marL="0">
               <a:buNone/>
             </a:pPr>
             <a:r>
               <a:rPr/>
-              <a:t>test</a:t>
+              <a:t>How does leaf size vary?</a:t>
+            </a:r>
+          </a:p>
+        </p:txBody>
+      </p:sp>
+      <p:sp>
+        <p:nvSpPr>
+          <p:cNvPr id="3" name="Content Placeholder 2"/>
+          <p:cNvSpPr>
+            <a:spLocks noGrp="1"/>
+          </p:cNvSpPr>
+          <p:nvPr>
+            <p:ph idx="1"/>
+          </p:nvPr>
+        </p:nvSpPr>
+        <p:spPr/>
+        <p:txBody>
+          <a:bodyPr/>
+          <a:lstStyle/>
+          <a:p>
+            <a:pPr lvl="0"/>
+            <a:r>
+              <a:rPr/>
+              <a:t>Does the sunny and shady sides of trees differ due to light?</a:t>
+            </a:r>
+          </a:p>
+          <a:p>
+            <a:pPr lvl="0"/>
+            <a:r>
+              <a:rPr/>
+              <a:t>What might we predict versus hypothesize</a:t>
+            </a:r>
+          </a:p>
+          <a:p>
+            <a:pPr lvl="1"/>
+            <a:r>
+              <a:rPr/>
+              <a:t>Predict</a:t>
+            </a:r>
+          </a:p>
+          <a:p>
+            <a:pPr lvl="1"/>
+            <a:r>
+              <a:rPr/>
+              <a:t>Hypothesize</a:t>
             </a:r>
           </a:p>
         </p:txBody>

</xml_diff>

<commit_message>
fixed up to 5
</commit_message>
<xml_diff>
--- a/docs/lectures/lecture_01/01_lecture_powerpoint.pptx
+++ b/docs/lectures/lecture_01/01_lecture_powerpoint.pptx
@@ -21,6 +21,7 @@
     <p:sldId id="269" r:id="rId15"/>
     <p:sldId id="270" r:id="rId16"/>
     <p:sldId id="271" r:id="rId17"/>
+    <p:sldId id="272" r:id="rId18"/>
   </p:sldIdLst>
   <p:sldSz cx="9144000" cy="5143500" type="screen16x9"/>
   <p:notesSz cx="6858000" cy="9144000"/>
@@ -3294,7 +3295,7 @@
             </a:pPr>
             <a:r>
               <a:rPr/>
-              <a:t>Lecture 01</a:t>
+              <a:t>Lecture 01 — Introduction</a:t>
             </a:r>
           </a:p>
         </p:txBody>
@@ -3324,7 +3325,38 @@
             </a:pPr>
             <a:r>
               <a:rPr/>
+              <a:t>Our question, our data, and a first look at what we will do</a:t>
+            </a:r>
+            <a:br/>
+            <a:br/>
+            <a:r>
+              <a:rPr/>
               <a:t>Bill Perry</a:t>
+            </a:r>
+          </a:p>
+        </p:txBody>
+      </p:sp>
+      <p:sp>
+        <p:nvSpPr>
+          <p:cNvPr id="4" name="Date Placeholder 3"/>
+          <p:cNvSpPr>
+            <a:spLocks noGrp="1"/>
+          </p:cNvSpPr>
+          <p:nvPr>
+            <p:ph idx="10" sz="half" type="dt"/>
+          </p:nvPr>
+        </p:nvSpPr>
+        <p:spPr/>
+        <p:txBody>
+          <a:bodyPr/>
+          <a:lstStyle/>
+          <a:p>
+            <a:pPr lvl="0" indent="0" marL="0">
+              <a:buNone/>
+            </a:pPr>
+            <a:r>
+              <a:rPr/>
+              <a:t>2026-06-28</a:t>
             </a:r>
           </a:p>
         </p:txBody>
@@ -3399,63 +3431,92 @@
             <a:pPr lvl="0"/>
             <a:r>
               <a:rPr/>
-              <a:t>Can we collect leaves from one tree to do this?</a:t>
+              <a:t>Can we collect leaves from </a:t>
+            </a:r>
+            <a:r>
+              <a:rPr b="1"/>
+              <a:t>one tree</a:t>
+            </a:r>
+            <a:r>
+              <a:rPr/>
+              <a:t> to do this?</a:t>
             </a:r>
           </a:p>
           <a:p>
             <a:pPr lvl="1"/>
             <a:r>
               <a:rPr/>
-              <a:t>YES?</a:t>
+              <a:t>YES? NO? — Discuss</a:t>
+            </a:r>
+          </a:p>
+          <a:p>
+            <a:pPr lvl="0"/>
+            <a:r>
+              <a:rPr/>
+              <a:t>What is the problem with using only one tree?</a:t>
+            </a:r>
+          </a:p>
+          <a:p>
+            <a:pPr lvl="0"/>
+            <a:r>
+              <a:rPr/>
+              <a:t>How might results from many trees differ from one tree?</a:t>
+            </a:r>
+          </a:p>
+          <a:p>
+            <a:pPr lvl="0"/>
+            <a:r>
+              <a:rPr/>
+              <a:t>Do we need to be sure our sample is </a:t>
+            </a:r>
+            <a:r>
+              <a:rPr b="1"/>
+              <a:t>randomly selected</a:t>
+            </a:r>
+            <a:r>
+              <a:rPr/>
+              <a:t>?</a:t>
             </a:r>
           </a:p>
           <a:p>
             <a:pPr lvl="1"/>
             <a:r>
               <a:rPr/>
-              <a:t>NO?</a:t>
+              <a:t>Why do we need to randomize?</a:t>
             </a:r>
           </a:p>
           <a:p>
             <a:pPr lvl="1"/>
             <a:r>
               <a:rPr/>
-              <a:t>Discuss</a:t>
-            </a:r>
-          </a:p>
-          <a:p>
-            <a:pPr lvl="0"/>
-            <a:r>
-              <a:rPr/>
-              <a:t>What might be the effect if we used only one tree?</a:t>
-            </a:r>
-          </a:p>
-          <a:p>
-            <a:pPr lvl="0"/>
-            <a:r>
-              <a:rPr/>
-              <a:t>How might that differ from many trees?</a:t>
-            </a:r>
-          </a:p>
-          <a:p>
-            <a:pPr lvl="0"/>
-            <a:r>
-              <a:rPr/>
-              <a:t>Do we need to be sure our sample is randomly selected?</a:t>
-            </a:r>
-          </a:p>
-          <a:p>
-            <a:pPr lvl="1"/>
-            <a:r>
-              <a:rPr/>
-              <a:t>why do we need to randomize sampling?</a:t>
-            </a:r>
-          </a:p>
-          <a:p>
-            <a:pPr lvl="1"/>
-            <a:r>
-              <a:rPr/>
-              <a:t>how can we randomize our sampling?</a:t>
+              <a:t>How can we randomize our sampling?</a:t>
+            </a:r>
+          </a:p>
+          <a:p>
+            <a:pPr lvl="0" indent="0" marL="1270000">
+              <a:buNone/>
+            </a:pPr>
+            <a:r>
+              <a:rPr sz="2000" b="1"/>
+              <a:t>Important</a:t>
+            </a:r>
+          </a:p>
+          <a:p>
+            <a:pPr lvl="0" indent="0" marL="1270000">
+              <a:buNone/>
+            </a:pPr>
+            <a:r>
+              <a:rPr sz="2000" b="1"/>
+              <a:t>Replication and randomization</a:t>
+            </a:r>
+          </a:p>
+          <a:p>
+            <a:pPr lvl="0" indent="0" marL="1270000">
+              <a:buNone/>
+            </a:pPr>
+            <a:r>
+              <a:rPr sz="2000"/>
+              <a:t>These two principles are the foundation of all experimental design. One tree is a sample size of one — we cannot generalize from that.</a:t>
             </a:r>
           </a:p>
         </p:txBody>
@@ -3495,8 +3556,11 @@
         <p:spPr>
           <a:xfrm>
             <a:off x="0" y="0"/>
-            <a:ext cx="9144000" cy="582780"/>
+            <a:ext cx="9144000" cy="602780"/>
           </a:xfrm>
+          <a:solidFill>
+            <a:srgbClr val="1A1A2E"/>
+          </a:solidFill>
         </p:spPr>
         <p:txBody>
           <a:bodyPr/>
@@ -3507,7 +3571,7 @@
             </a:pPr>
             <a:r>
               <a:rPr/>
-              <a:t>What are the different variables we could record?</a:t>
+              <a:t>What variables could we record?</a:t>
             </a:r>
           </a:p>
         </p:txBody>
@@ -3519,7 +3583,7 @@
             <a:spLocks noGrp="1"/>
           </p:cNvSpPr>
           <p:nvPr>
-            <p:ph idx="1"/>
+            <p:ph idx="1" sz="half"/>
           </p:nvPr>
         </p:nvSpPr>
         <p:spPr/>
@@ -3530,42 +3594,133 @@
             <a:pPr lvl="0"/>
             <a:r>
               <a:rPr/>
-              <a:t>What variables could we record about the tree?</a:t>
-            </a:r>
-          </a:p>
-          <a:p>
-            <a:pPr lvl="0"/>
-            <a:r>
-              <a:rPr/>
-              <a:t>What variables could we record about the leaf?</a:t>
-            </a:r>
-          </a:p>
-          <a:p>
-            <a:pPr lvl="1"/>
-            <a:r>
-              <a:rPr/>
-              <a:t>what is a dependent variable?</a:t>
-            </a:r>
-          </a:p>
-          <a:p>
-            <a:pPr lvl="2"/>
-            <a:r>
-              <a:rPr/>
-              <a:t>[class discussion here]</a:t>
-            </a:r>
-          </a:p>
-          <a:p>
-            <a:pPr lvl="1"/>
-            <a:r>
-              <a:rPr/>
-              <a:t>what is an independent variable?</a:t>
-            </a:r>
-          </a:p>
-          <a:p>
-            <a:pPr lvl="2"/>
-            <a:r>
-              <a:rPr/>
-              <a:t>[class discussion here]</a:t>
+              <a:t>What variables could we record about the </a:t>
+            </a:r>
+            <a:r>
+              <a:rPr b="1"/>
+              <a:t>tree</a:t>
+            </a:r>
+            <a:r>
+              <a:rPr/>
+              <a:t>?</a:t>
+            </a:r>
+          </a:p>
+          <a:p>
+            <a:pPr lvl="0"/>
+            <a:r>
+              <a:rPr/>
+              <a:t>What variables could we record about the </a:t>
+            </a:r>
+            <a:r>
+              <a:rPr b="1"/>
+              <a:t>leaf</a:t>
+            </a:r>
+            <a:r>
+              <a:rPr/>
+              <a:t>?</a:t>
+            </a:r>
+          </a:p>
+          <a:p>
+            <a:pPr lvl="0" indent="0" marL="0">
+              <a:buNone/>
+            </a:pPr>
+            <a:r>
+              <a:rPr b="1"/>
+              <a:t>Dependent variable (response):</a:t>
+            </a:r>
+            <a:r>
+              <a:rPr/>
+              <a:t> - The thing we measure — it </a:t>
+            </a:r>
+            <a:r>
+              <a:rPr i="1"/>
+              <a:t>depends on</a:t>
+            </a:r>
+            <a:r>
+              <a:rPr/>
+              <a:t> our treatment - Example: leaf mass, leaf area</a:t>
+            </a:r>
+          </a:p>
+          <a:p>
+            <a:pPr lvl="0" indent="0" marL="0">
+              <a:buNone/>
+            </a:pPr>
+            <a:r>
+              <a:rPr b="1"/>
+              <a:t>Independent variable (explanatory):</a:t>
+            </a:r>
+            <a:r>
+              <a:rPr/>
+              <a:t> - The thing we control or group by - Example: side of tree (sunny vs. shady)</a:t>
+            </a:r>
+          </a:p>
+        </p:txBody>
+      </p:sp>
+      <p:sp>
+        <p:nvSpPr>
+          <p:cNvPr id="4" name="Content Placeholder 3"/>
+          <p:cNvSpPr>
+            <a:spLocks noGrp="1"/>
+          </p:cNvSpPr>
+          <p:nvPr>
+            <p:ph idx="2" sz="half"/>
+          </p:nvPr>
+        </p:nvSpPr>
+        <p:spPr/>
+        <p:txBody>
+          <a:bodyPr/>
+          <a:lstStyle/>
+          <a:p>
+            <a:pPr lvl="0" indent="0" marL="1270000">
+              <a:buNone/>
+            </a:pPr>
+            <a:r>
+              <a:rPr sz="2000" b="1"/>
+              <a:t>Note</a:t>
+            </a:r>
+          </a:p>
+          <a:p>
+            <a:pPr lvl="0" indent="0" marL="1270000">
+              <a:buNone/>
+            </a:pPr>
+            <a:r>
+              <a:rPr sz="2000" b="1"/>
+              <a:t>📖 New vocabulary</a:t>
+            </a:r>
+          </a:p>
+          <a:p>
+            <a:pPr lvl="0" indent="0" marL="1270000">
+              <a:buNone/>
+            </a:pPr>
+            <a:r>
+              <a:rPr sz="2000" b="1"/>
+              <a:t>Dependent variable</a:t>
+            </a:r>
+            <a:r>
+              <a:rPr sz="2000"/>
+              <a:t> → what you measure (Y)</a:t>
+            </a:r>
+          </a:p>
+          <a:p>
+            <a:pPr lvl="0" indent="0" marL="1270000">
+              <a:buNone/>
+            </a:pPr>
+            <a:r>
+              <a:rPr sz="2000" b="1"/>
+              <a:t>Independent variable</a:t>
+            </a:r>
+            <a:r>
+              <a:rPr sz="2000"/>
+              <a:t> → what you control or group by (X)</a:t>
+            </a:r>
+          </a:p>
+          <a:p>
+            <a:pPr lvl="0" indent="0" marL="1270000">
+              <a:buNone/>
+            </a:pPr>
+            <a:r>
+              <a:rPr sz="2000"/>
+              <a:t>In a graph: Y goes on the vertical axis, X goes on the horizontal axis.</a:t>
             </a:r>
           </a:p>
         </p:txBody>
@@ -3640,35 +3795,101 @@
             <a:pPr lvl="0"/>
             <a:r>
               <a:rPr/>
-              <a:t>How can we standardize our collections?</a:t>
+              <a:t>Collect </a:t>
+            </a:r>
+            <a:r>
+              <a:rPr b="1"/>
+              <a:t>1 mature leaf from the sunny side</a:t>
+            </a:r>
+            <a:r>
+              <a:rPr/>
+              <a:t> and </a:t>
+            </a:r>
+            <a:r>
+              <a:rPr b="1"/>
+              <a:t>1 from the shady side</a:t>
+            </a:r>
+            <a:r>
+              <a:rPr/>
+              <a:t> of the same tree</a:t>
+            </a:r>
+          </a:p>
+          <a:p>
+            <a:pPr lvl="0"/>
+            <a:r>
+              <a:rPr/>
+              <a:t>Do this on </a:t>
+            </a:r>
+            <a:r>
+              <a:rPr b="1"/>
+              <a:t>at least 2 separate trees</a:t>
+            </a:r>
+            <a:r>
+              <a:rPr/>
+              <a:t> (we share trees since we are limited)</a:t>
+            </a:r>
+          </a:p>
+          <a:p>
+            <a:pPr lvl="0"/>
+            <a:r>
+              <a:rPr/>
+              <a:t>Standardize your collection:</a:t>
             </a:r>
           </a:p>
           <a:p>
             <a:pPr lvl="1"/>
             <a:r>
               <a:rPr/>
-              <a:t>A mature leaf from the sunny side and 1 leaf from the shady side?</a:t>
+              <a:t>How high do we collect from?</a:t>
             </a:r>
           </a:p>
           <a:p>
             <a:pPr lvl="1"/>
             <a:r>
               <a:rPr/>
-              <a:t>Do this on 2 separate trees - and for this we can use the trees others use as we are limited</a:t>
-            </a:r>
-          </a:p>
-          <a:p>
-            <a:pPr lvl="0"/>
-            <a:r>
-              <a:rPr/>
-              <a:t>How high do we collect?</a:t>
-            </a:r>
-          </a:p>
-          <a:p>
-            <a:pPr lvl="0"/>
-            <a:r>
-              <a:rPr/>
-              <a:t>Are there other things to do?</a:t>
+              <a:t>What does “mature” mean?</a:t>
+            </a:r>
+          </a:p>
+          <a:p>
+            <a:pPr lvl="1"/>
+            <a:r>
+              <a:rPr/>
+              <a:t>Any other decisions to standardize?</a:t>
+            </a:r>
+          </a:p>
+          <a:p>
+            <a:pPr lvl="0" indent="0" marL="1270000">
+              <a:buNone/>
+            </a:pPr>
+            <a:r>
+              <a:rPr sz="2000" b="1"/>
+              <a:t>Important</a:t>
+            </a:r>
+          </a:p>
+          <a:p>
+            <a:pPr lvl="0" indent="0" marL="1270000">
+              <a:buNone/>
+            </a:pPr>
+            <a:r>
+              <a:rPr sz="2000" b="1"/>
+              <a:t>⚠️ Watch out!</a:t>
+            </a:r>
+          </a:p>
+          <a:p>
+            <a:pPr lvl="0" indent="0" marL="1270000">
+              <a:buNone/>
+            </a:pPr>
+            <a:r>
+              <a:rPr sz="2000"/>
+              <a:t>If everyone collects differently (different heights, different leaf ages), we cannot combine our data. Agree on the rules </a:t>
+            </a:r>
+            <a:r>
+              <a:rPr sz="2000" b="1"/>
+              <a:t>before</a:t>
+            </a:r>
+            <a:r>
+              <a:rPr sz="2000"/>
+              <a:t> collecting.</a:t>
             </a:r>
           </a:p>
         </p:txBody>
@@ -3708,8 +3929,11 @@
         <p:spPr>
           <a:xfrm>
             <a:off x="0" y="0"/>
-            <a:ext cx="9144000" cy="582780"/>
+            <a:ext cx="9144000" cy="602780"/>
           </a:xfrm>
+          <a:solidFill>
+            <a:srgbClr val="1A1A2E"/>
+          </a:solidFill>
         </p:spPr>
         <p:txBody>
           <a:bodyPr/>
@@ -3720,7 +3944,7 @@
             </a:pPr>
             <a:r>
               <a:rPr/>
-              <a:t>Back in the laboratory - before we even begin</a:t>
+              <a:t>Back in the lab · Before we begin</a:t>
             </a:r>
           </a:p>
         </p:txBody>
@@ -3732,7 +3956,7 @@
             <a:spLocks noGrp="1"/>
           </p:cNvSpPr>
           <p:nvPr>
-            <p:ph idx="1"/>
+            <p:ph idx="1" sz="half"/>
           </p:nvPr>
         </p:nvSpPr>
         <p:spPr/>
@@ -3740,52 +3964,150 @@
           <a:bodyPr/>
           <a:lstStyle/>
           <a:p>
-            <a:pPr lvl="0"/>
-            <a:r>
-              <a:rPr/>
-              <a:t>What are the steps we need to decide on when processing this data?</a:t>
-            </a:r>
-          </a:p>
-          <a:p>
-            <a:pPr lvl="0"/>
-            <a:r>
-              <a:rPr/>
+            <a:pPr lvl="0" indent="0" marL="0">
+              <a:buNone/>
+            </a:pPr>
+            <a:r>
+              <a:rPr b="1"/>
               <a:t>What can we measure?</a:t>
             </a:r>
           </a:p>
           <a:p>
-            <a:pPr lvl="1"/>
-            <a:r>
-              <a:rPr/>
-              <a:t>mass?</a:t>
-            </a:r>
-          </a:p>
-          <a:p>
-            <a:pPr lvl="1"/>
-            <a:r>
-              <a:rPr/>
-              <a:t>length?</a:t>
-            </a:r>
-          </a:p>
-          <a:p>
-            <a:pPr lvl="1"/>
-            <a:r>
-              <a:rPr/>
-              <a:t>width?</a:t>
-            </a:r>
-          </a:p>
-          <a:p>
-            <a:pPr lvl="1"/>
-            <a:r>
-              <a:rPr/>
-              <a:t>surface area?</a:t>
-            </a:r>
-          </a:p>
-          <a:p>
-            <a:pPr lvl="1"/>
+            <a:pPr lvl="0"/>
+            <a:r>
+              <a:rPr/>
+              <a:t>mass (grams)</a:t>
+            </a:r>
+          </a:p>
+          <a:p>
+            <a:pPr lvl="0"/>
+            <a:r>
+              <a:rPr/>
+              <a:t>length (mm or cm)</a:t>
+            </a:r>
+          </a:p>
+          <a:p>
+            <a:pPr lvl="0"/>
+            <a:r>
+              <a:rPr/>
+              <a:t>width (mm or cm)</a:t>
+            </a:r>
+          </a:p>
+          <a:p>
+            <a:pPr lvl="0"/>
+            <a:r>
+              <a:rPr/>
+              <a:t>surface area (cm²) — how?</a:t>
+            </a:r>
+          </a:p>
+          <a:p>
+            <a:pPr lvl="0"/>
             <a:r>
               <a:rPr/>
               <a:t>others?</a:t>
+            </a:r>
+          </a:p>
+          <a:p>
+            <a:pPr lvl="0" indent="0" marL="0">
+              <a:buNone/>
+            </a:pPr>
+            <a:r>
+              <a:rPr b="1"/>
+              <a:t>Decisions to make as a group:</a:t>
+            </a:r>
+          </a:p>
+          <a:p>
+            <a:pPr lvl="0"/>
+            <a:r>
+              <a:rPr/>
+              <a:t>What units?</a:t>
+            </a:r>
+          </a:p>
+          <a:p>
+            <a:pPr lvl="0"/>
+            <a:r>
+              <a:rPr/>
+              <a:t>What abbreviations?</a:t>
+            </a:r>
+          </a:p>
+          <a:p>
+            <a:pPr lvl="0"/>
+            <a:r>
+              <a:rPr/>
+              <a:t>What if a leaf is damaged?</a:t>
+            </a:r>
+          </a:p>
+        </p:txBody>
+      </p:sp>
+      <p:sp>
+        <p:nvSpPr>
+          <p:cNvPr id="4" name="Content Placeholder 3"/>
+          <p:cNvSpPr>
+            <a:spLocks noGrp="1"/>
+          </p:cNvSpPr>
+          <p:nvPr>
+            <p:ph idx="2" sz="half"/>
+          </p:nvPr>
+        </p:nvSpPr>
+        <p:spPr/>
+        <p:txBody>
+          <a:bodyPr/>
+          <a:lstStyle/>
+          <a:p>
+            <a:pPr lvl="0" indent="0" marL="1270000">
+              <a:buNone/>
+            </a:pPr>
+            <a:r>
+              <a:rPr sz="2000" b="1"/>
+              <a:t>Note</a:t>
+            </a:r>
+          </a:p>
+          <a:p>
+            <a:pPr lvl="0" indent="0" marL="1270000">
+              <a:buNone/>
+            </a:pPr>
+            <a:r>
+              <a:rPr sz="2000" b="1"/>
+              <a:t>📖 New vocabulary</a:t>
+            </a:r>
+          </a:p>
+          <a:p>
+            <a:pPr lvl="0" indent="0" marL="1270000">
+              <a:buNone/>
+            </a:pPr>
+            <a:r>
+              <a:rPr sz="2000" b="1"/>
+              <a:t>Metadata</a:t>
+            </a:r>
+            <a:r>
+              <a:rPr sz="2000"/>
+              <a:t> = data </a:t>
+            </a:r>
+            <a:r>
+              <a:rPr sz="2000" i="1"/>
+              <a:t>about</a:t>
+            </a:r>
+            <a:r>
+              <a:rPr sz="2000"/>
+              <a:t> your data.</a:t>
+            </a:r>
+          </a:p>
+          <a:p>
+            <a:pPr lvl="0" indent="0" marL="1270000">
+              <a:buNone/>
+            </a:pPr>
+            <a:r>
+              <a:rPr sz="2000"/>
+              <a:t>Who collected it? When? Where? With what instrument? Under what conditions?</a:t>
+            </a:r>
+          </a:p>
+          <a:p>
+            <a:pPr lvl="0" indent="0" marL="1270000">
+              <a:buNone/>
+            </a:pPr>
+            <a:r>
+              <a:rPr sz="2000"/>
+              <a:t>Without metadata, data are nearly useless to anyone else — including future you.</a:t>
             </a:r>
           </a:p>
         </p:txBody>
@@ -3837,7 +4159,7 @@
             </a:pPr>
             <a:r>
               <a:rPr/>
-              <a:t>Back in the laboratory - before we even begin</a:t>
+              <a:t>Back in the lab · Setting up the spreadsheet</a:t>
             </a:r>
           </a:p>
         </p:txBody>
@@ -3860,42 +4182,132 @@
             <a:pPr lvl="0"/>
             <a:r>
               <a:rPr/>
-              <a:t>How do you enter this into the excel sheet</a:t>
+              <a:t>How do you enter this into the Excel sheet?</a:t>
             </a:r>
           </a:p>
           <a:p>
             <a:pPr lvl="1"/>
             <a:r>
               <a:rPr/>
-              <a:t>what does the sheet look like - mock up something to show the rest of the class?</a:t>
-            </a:r>
-          </a:p>
-          <a:p>
-            <a:pPr lvl="0"/>
-            <a:r>
-              <a:rPr/>
-              <a:t>What are the terms you will use?</a:t>
-            </a:r>
-          </a:p>
-          <a:p>
-            <a:pPr lvl="0"/>
-            <a:r>
-              <a:rPr/>
-              <a:t>What are the units?</a:t>
-            </a:r>
-          </a:p>
-          <a:p>
-            <a:pPr lvl="0"/>
-            <a:r>
-              <a:rPr/>
-              <a:t>What is meta data?</a:t>
-            </a:r>
-          </a:p>
-          <a:p>
-            <a:pPr lvl="0"/>
-            <a:r>
-              <a:rPr/>
-              <a:t>What vocabulary do you use?</a:t>
+              <a:t>What does the sheet look like? Mock something up</a:t>
+            </a:r>
+          </a:p>
+          <a:p>
+            <a:pPr lvl="0"/>
+            <a:r>
+              <a:rPr/>
+              <a:t>What are the </a:t>
+            </a:r>
+            <a:r>
+              <a:rPr b="1"/>
+              <a:t>column names</a:t>
+            </a:r>
+            <a:r>
+              <a:rPr/>
+              <a:t> you will use?</a:t>
+            </a:r>
+          </a:p>
+          <a:p>
+            <a:pPr lvl="0"/>
+            <a:r>
+              <a:rPr/>
+              <a:t>What are the </a:t>
+            </a:r>
+            <a:r>
+              <a:rPr b="1"/>
+              <a:t>units</a:t>
+            </a:r>
+            <a:r>
+              <a:rPr/>
+              <a:t> for each column?</a:t>
+            </a:r>
+          </a:p>
+          <a:p>
+            <a:pPr lvl="0"/>
+            <a:r>
+              <a:rPr/>
+              <a:t>What is the </a:t>
+            </a:r>
+            <a:r>
+              <a:rPr b="1"/>
+              <a:t>vocabulary</a:t>
+            </a:r>
+            <a:r>
+              <a:rPr/>
+              <a:t>? (no spaces in column names, use </a:t>
+            </a:r>
+            <a:r>
+              <a:rPr>
+                <a:latin typeface="Courier"/>
+              </a:rPr>
+              <a:t>_</a:t>
+            </a:r>
+            <a:r>
+              <a:rPr/>
+              <a:t> instead)</a:t>
+            </a:r>
+          </a:p>
+          <a:p>
+            <a:pPr lvl="0"/>
+            <a:r>
+              <a:rPr/>
+              <a:t>Where does the </a:t>
+            </a:r>
+            <a:r>
+              <a:rPr b="1"/>
+              <a:t>metadata</a:t>
+            </a:r>
+            <a:r>
+              <a:rPr/>
+              <a:t> go?</a:t>
+            </a:r>
+          </a:p>
+          <a:p>
+            <a:pPr lvl="0" indent="0" marL="1270000">
+              <a:buNone/>
+            </a:pPr>
+            <a:r>
+              <a:rPr sz="2000" b="1"/>
+              <a:t>Tip</a:t>
+            </a:r>
+          </a:p>
+          <a:p>
+            <a:pPr lvl="0" indent="0" marL="1270000">
+              <a:buNone/>
+            </a:pPr>
+            <a:r>
+              <a:rPr sz="2000" b="1"/>
+              <a:t>Best practice for column names:</a:t>
+            </a:r>
+          </a:p>
+          <a:p>
+            <a:pPr lvl="0" indent="0" marL="1270000">
+              <a:buNone/>
+            </a:pPr>
+            <a:r>
+              <a:rPr sz="2000">
+                <a:latin typeface="Courier"/>
+              </a:rPr>
+              <a:t>leaf_mass_g</a:t>
+            </a:r>
+            <a:r>
+              <a:rPr sz="2000"/>
+              <a:t>, not </a:t>
+            </a:r>
+            <a:r>
+              <a:rPr sz="2000">
+                <a:latin typeface="Courier"/>
+              </a:rPr>
+              <a:t>Leaf Mass (g)</a:t>
+            </a:r>
+          </a:p>
+          <a:p>
+            <a:pPr lvl="0" indent="0" marL="1270000">
+              <a:buNone/>
+            </a:pPr>
+            <a:r>
+              <a:rPr sz="2000"/>
+              <a:t>Consistent, no spaces, no special characters, units in the name.</a:t>
             </a:r>
           </a:p>
         </p:txBody>
@@ -3947,7 +4359,7 @@
             </a:pPr>
             <a:r>
               <a:rPr/>
-              <a:t>Can you make a graph of the data in Excel based on what we collected?</a:t>
+              <a:t>Can you make a graph in Excel?</a:t>
             </a:r>
           </a:p>
         </p:txBody>
@@ -3970,14 +4382,46 @@
             <a:pPr lvl="0"/>
             <a:r>
               <a:rPr/>
-              <a:t>what would the graph look like?</a:t>
-            </a:r>
-          </a:p>
-          <a:p>
-            <a:pPr lvl="0"/>
-            <a:r>
-              <a:rPr/>
-              <a:t>what can you derive from the data?</a:t>
+              <a:t>Using what you collected, make a simple Excel chart</a:t>
+            </a:r>
+          </a:p>
+          <a:p>
+            <a:pPr lvl="1"/>
+            <a:r>
+              <a:rPr/>
+              <a:t>What would the graph look like?</a:t>
+            </a:r>
+          </a:p>
+          <a:p>
+            <a:pPr lvl="1"/>
+            <a:r>
+              <a:rPr/>
+              <a:t>What goes on the X axis? The Y axis?</a:t>
+            </a:r>
+          </a:p>
+          <a:p>
+            <a:pPr lvl="1"/>
+            <a:r>
+              <a:rPr/>
+              <a:t>What can you derive from the data already?</a:t>
+            </a:r>
+          </a:p>
+          <a:p>
+            <a:pPr lvl="0" indent="0" marL="1270000">
+              <a:buNone/>
+            </a:pPr>
+            <a:r>
+              <a:rPr sz="2000" b="1"/>
+              <a:t>Note</a:t>
+            </a:r>
+          </a:p>
+          <a:p>
+            <a:pPr lvl="0" indent="0" marL="1270000">
+              <a:buNone/>
+            </a:pPr>
+            <a:r>
+              <a:rPr sz="2000"/>
+              <a:t>Excel is great for a first look. But as datasets grow larger and analyses more complex, we need R. Starting Thursday you will see why.</a:t>
             </a:r>
           </a:p>
         </p:txBody>
@@ -4029,7 +4473,480 @@
             </a:pPr>
             <a:r>
               <a:rPr/>
-              <a:t>Before Thursday Install R and Positron</a:t>
+              <a:t>What R code looks like · A preview</a:t>
+            </a:r>
+          </a:p>
+        </p:txBody>
+      </p:sp>
+      <p:sp>
+        <p:nvSpPr>
+          <p:cNvPr id="3" name="Content Placeholder 2"/>
+          <p:cNvSpPr>
+            <a:spLocks noGrp="1"/>
+          </p:cNvSpPr>
+          <p:nvPr>
+            <p:ph idx="1"/>
+          </p:nvPr>
+        </p:nvSpPr>
+        <p:spPr/>
+        <p:txBody>
+          <a:bodyPr/>
+          <a:lstStyle/>
+          <a:p>
+            <a:pPr lvl="0" indent="0" marL="0">
+              <a:buNone/>
+            </a:pPr>
+            <a:r>
+              <a:rPr/>
+              <a:t>You do not need to understand this yet — just look at the shape of it.</a:t>
+            </a:r>
+          </a:p>
+          <a:p>
+            <a:pPr lvl="0" indent="0">
+              <a:buNone/>
+            </a:pPr>
+            <a:r>
+              <a:rPr>
+                <a:solidFill>
+                  <a:srgbClr val="5E5E5E"/>
+                </a:solidFill>
+                <a:latin typeface="Courier"/>
+              </a:rPr>
+              <a:t># Load the tools we need</a:t>
+            </a:r>
+            <a:br/>
+            <a:r>
+              <a:rPr>
+                <a:solidFill>
+                  <a:srgbClr val="4758AB"/>
+                </a:solidFill>
+                <a:latin typeface="Courier"/>
+              </a:rPr>
+              <a:t>library</a:t>
+            </a:r>
+            <a:r>
+              <a:rPr>
+                <a:solidFill>
+                  <a:srgbClr val="003B4F"/>
+                </a:solidFill>
+                <a:latin typeface="Courier"/>
+              </a:rPr>
+              <a:t>(tidyverse)</a:t>
+            </a:r>
+            <a:br/>
+            <a:r>
+              <a:rPr>
+                <a:solidFill>
+                  <a:srgbClr val="4758AB"/>
+                </a:solidFill>
+                <a:latin typeface="Courier"/>
+              </a:rPr>
+              <a:t>library</a:t>
+            </a:r>
+            <a:r>
+              <a:rPr>
+                <a:solidFill>
+                  <a:srgbClr val="003B4F"/>
+                </a:solidFill>
+                <a:latin typeface="Courier"/>
+              </a:rPr>
+              <a:t>(readxl)</a:t>
+            </a:r>
+            <a:br/>
+            <a:br/>
+            <a:r>
+              <a:rPr>
+                <a:solidFill>
+                  <a:srgbClr val="5E5E5E"/>
+                </a:solidFill>
+                <a:latin typeface="Courier"/>
+              </a:rPr>
+              <a:t># Read our leaf data into R</a:t>
+            </a:r>
+            <a:br/>
+            <a:r>
+              <a:rPr>
+                <a:solidFill>
+                  <a:srgbClr val="003B4F"/>
+                </a:solidFill>
+                <a:latin typeface="Courier"/>
+              </a:rPr>
+              <a:t>tree_df &lt;- </a:t>
+            </a:r>
+            <a:r>
+              <a:rPr>
+                <a:solidFill>
+                  <a:srgbClr val="4758AB"/>
+                </a:solidFill>
+                <a:latin typeface="Courier"/>
+              </a:rPr>
+              <a:t>read_excel</a:t>
+            </a:r>
+            <a:r>
+              <a:rPr>
+                <a:solidFill>
+                  <a:srgbClr val="003B4F"/>
+                </a:solidFill>
+                <a:latin typeface="Courier"/>
+              </a:rPr>
+              <a:t>(</a:t>
+            </a:r>
+            <a:r>
+              <a:rPr>
+                <a:solidFill>
+                  <a:srgbClr val="20794D"/>
+                </a:solidFill>
+                <a:latin typeface="Courier"/>
+              </a:rPr>
+              <a:t>"data/tree_experiment.xlsx"</a:t>
+            </a:r>
+            <a:r>
+              <a:rPr>
+                <a:solidFill>
+                  <a:srgbClr val="003B4F"/>
+                </a:solidFill>
+                <a:latin typeface="Courier"/>
+              </a:rPr>
+              <a:t>)</a:t>
+            </a:r>
+            <a:br/>
+            <a:br/>
+            <a:r>
+              <a:rPr>
+                <a:solidFill>
+                  <a:srgbClr val="5E5E5E"/>
+                </a:solidFill>
+                <a:latin typeface="Courier"/>
+              </a:rPr>
+              <a:t># Compute the mean weight for each side</a:t>
+            </a:r>
+            <a:br/>
+            <a:r>
+              <a:rPr>
+                <a:solidFill>
+                  <a:srgbClr val="003B4F"/>
+                </a:solidFill>
+                <a:latin typeface="Courier"/>
+              </a:rPr>
+              <a:t>tree_df </a:t>
+            </a:r>
+            <a:r>
+              <a:rPr>
+                <a:solidFill>
+                  <a:srgbClr val="5E5E5E"/>
+                </a:solidFill>
+                <a:latin typeface="Courier"/>
+              </a:rPr>
+              <a:t>%&gt;%</a:t>
+            </a:r>
+            <a:br/>
+            <a:r>
+              <a:rPr>
+                <a:solidFill>
+                  <a:srgbClr val="003B4F"/>
+                </a:solidFill>
+                <a:latin typeface="Courier"/>
+              </a:rPr>
+              <a:t>  </a:t>
+            </a:r>
+            <a:r>
+              <a:rPr>
+                <a:solidFill>
+                  <a:srgbClr val="4758AB"/>
+                </a:solidFill>
+                <a:latin typeface="Courier"/>
+              </a:rPr>
+              <a:t>group_by</a:t>
+            </a:r>
+            <a:r>
+              <a:rPr>
+                <a:solidFill>
+                  <a:srgbClr val="003B4F"/>
+                </a:solidFill>
+                <a:latin typeface="Courier"/>
+              </a:rPr>
+              <a:t>(side) </a:t>
+            </a:r>
+            <a:r>
+              <a:rPr>
+                <a:solidFill>
+                  <a:srgbClr val="5E5E5E"/>
+                </a:solidFill>
+                <a:latin typeface="Courier"/>
+              </a:rPr>
+              <a:t>%&gt;%</a:t>
+            </a:r>
+            <a:br/>
+            <a:r>
+              <a:rPr>
+                <a:solidFill>
+                  <a:srgbClr val="003B4F"/>
+                </a:solidFill>
+                <a:latin typeface="Courier"/>
+              </a:rPr>
+              <a:t>  </a:t>
+            </a:r>
+            <a:r>
+              <a:rPr>
+                <a:solidFill>
+                  <a:srgbClr val="4758AB"/>
+                </a:solidFill>
+                <a:latin typeface="Courier"/>
+              </a:rPr>
+              <a:t>summarize</a:t>
+            </a:r>
+            <a:r>
+              <a:rPr>
+                <a:solidFill>
+                  <a:srgbClr val="003B4F"/>
+                </a:solidFill>
+                <a:latin typeface="Courier"/>
+              </a:rPr>
+              <a:t>(</a:t>
+            </a:r>
+            <a:r>
+              <a:rPr>
+                <a:solidFill>
+                  <a:srgbClr val="657422"/>
+                </a:solidFill>
+                <a:latin typeface="Courier"/>
+              </a:rPr>
+              <a:t>mean_weight =</a:t>
+            </a:r>
+            <a:r>
+              <a:rPr>
+                <a:solidFill>
+                  <a:srgbClr val="003B4F"/>
+                </a:solidFill>
+                <a:latin typeface="Courier"/>
+              </a:rPr>
+              <a:t> </a:t>
+            </a:r>
+            <a:r>
+              <a:rPr>
+                <a:solidFill>
+                  <a:srgbClr val="4758AB"/>
+                </a:solidFill>
+                <a:latin typeface="Courier"/>
+              </a:rPr>
+              <a:t>mean</a:t>
+            </a:r>
+            <a:r>
+              <a:rPr>
+                <a:solidFill>
+                  <a:srgbClr val="003B4F"/>
+                </a:solidFill>
+                <a:latin typeface="Courier"/>
+              </a:rPr>
+              <a:t>(weight_g))</a:t>
+            </a:r>
+            <a:br/>
+            <a:br/>
+            <a:r>
+              <a:rPr>
+                <a:solidFill>
+                  <a:srgbClr val="5E5E5E"/>
+                </a:solidFill>
+                <a:latin typeface="Courier"/>
+              </a:rPr>
+              <a:t># Make a plot</a:t>
+            </a:r>
+            <a:br/>
+            <a:r>
+              <a:rPr>
+                <a:solidFill>
+                  <a:srgbClr val="4758AB"/>
+                </a:solidFill>
+                <a:latin typeface="Courier"/>
+              </a:rPr>
+              <a:t>ggplot</a:t>
+            </a:r>
+            <a:r>
+              <a:rPr>
+                <a:solidFill>
+                  <a:srgbClr val="003B4F"/>
+                </a:solidFill>
+                <a:latin typeface="Courier"/>
+              </a:rPr>
+              <a:t>(tree_df, </a:t>
+            </a:r>
+            <a:r>
+              <a:rPr>
+                <a:solidFill>
+                  <a:srgbClr val="4758AB"/>
+                </a:solidFill>
+                <a:latin typeface="Courier"/>
+              </a:rPr>
+              <a:t>aes</a:t>
+            </a:r>
+            <a:r>
+              <a:rPr>
+                <a:solidFill>
+                  <a:srgbClr val="003B4F"/>
+                </a:solidFill>
+                <a:latin typeface="Courier"/>
+              </a:rPr>
+              <a:t>(</a:t>
+            </a:r>
+            <a:r>
+              <a:rPr>
+                <a:solidFill>
+                  <a:srgbClr val="657422"/>
+                </a:solidFill>
+                <a:latin typeface="Courier"/>
+              </a:rPr>
+              <a:t>x =</a:t>
+            </a:r>
+            <a:r>
+              <a:rPr>
+                <a:solidFill>
+                  <a:srgbClr val="003B4F"/>
+                </a:solidFill>
+                <a:latin typeface="Courier"/>
+              </a:rPr>
+              <a:t> side, </a:t>
+            </a:r>
+            <a:r>
+              <a:rPr>
+                <a:solidFill>
+                  <a:srgbClr val="657422"/>
+                </a:solidFill>
+                <a:latin typeface="Courier"/>
+              </a:rPr>
+              <a:t>y =</a:t>
+            </a:r>
+            <a:r>
+              <a:rPr>
+                <a:solidFill>
+                  <a:srgbClr val="003B4F"/>
+                </a:solidFill>
+                <a:latin typeface="Courier"/>
+              </a:rPr>
+              <a:t> weight_g)) </a:t>
+            </a:r>
+            <a:r>
+              <a:rPr>
+                <a:solidFill>
+                  <a:srgbClr val="5E5E5E"/>
+                </a:solidFill>
+                <a:latin typeface="Courier"/>
+              </a:rPr>
+              <a:t>+</a:t>
+            </a:r>
+            <a:br/>
+            <a:r>
+              <a:rPr>
+                <a:solidFill>
+                  <a:srgbClr val="003B4F"/>
+                </a:solidFill>
+                <a:latin typeface="Courier"/>
+              </a:rPr>
+              <a:t>  </a:t>
+            </a:r>
+            <a:r>
+              <a:rPr>
+                <a:solidFill>
+                  <a:srgbClr val="4758AB"/>
+                </a:solidFill>
+                <a:latin typeface="Courier"/>
+              </a:rPr>
+              <a:t>geom_boxplot</a:t>
+            </a:r>
+            <a:r>
+              <a:rPr>
+                <a:solidFill>
+                  <a:srgbClr val="003B4F"/>
+                </a:solidFill>
+                <a:latin typeface="Courier"/>
+              </a:rPr>
+              <a:t>()</a:t>
+            </a:r>
+          </a:p>
+          <a:p>
+            <a:pPr lvl="0" indent="0" marL="1270000">
+              <a:buNone/>
+            </a:pPr>
+            <a:r>
+              <a:rPr sz="2000" b="1"/>
+              <a:t>Tip</a:t>
+            </a:r>
+          </a:p>
+          <a:p>
+            <a:pPr lvl="0" indent="0" marL="1270000">
+              <a:buNone/>
+            </a:pPr>
+            <a:r>
+              <a:rPr sz="2000" b="1"/>
+              <a:t>🖐 Notice</a:t>
+            </a:r>
+          </a:p>
+          <a:p>
+            <a:pPr lvl="0" indent="0" marL="1270000">
+              <a:buNone/>
+            </a:pPr>
+            <a:r>
+              <a:rPr sz="2000"/>
+              <a:t>It reads almost like English: </a:t>
+            </a:r>
+            <a:r>
+              <a:rPr sz="2000" i="1"/>
+              <a:t>take tree_df, then group by side, then compute the mean</a:t>
+            </a:r>
+            <a:r>
+              <a:rPr sz="2000"/>
+              <a:t>. That is the goal — code that tells a clear story.</a:t>
+            </a:r>
+          </a:p>
+        </p:txBody>
+      </p:sp>
+    </p:spTree>
+  </p:cSld>
+</p:sld>
+</file>
+
+<file path=ppt/slides/slide17.xml><?xml version="1.0" encoding="utf-8"?>
+<p:sld xmlns:a="http://schemas.openxmlformats.org/drawingml/2006/main" xmlns:r="http://schemas.openxmlformats.org/officeDocument/2006/relationships" xmlns:p="http://schemas.openxmlformats.org/presentationml/2006/main">
+  <p:cSld>
+    <p:spTree>
+      <p:nvGrpSpPr>
+        <p:cNvPr id="1" name=""/>
+        <p:cNvGrpSpPr/>
+        <p:nvPr/>
+      </p:nvGrpSpPr>
+      <p:grpSpPr>
+        <a:xfrm>
+          <a:off x="0" y="0"/>
+          <a:ext cx="0" cy="0"/>
+          <a:chOff x="0" y="0"/>
+          <a:chExt cx="0" cy="0"/>
+        </a:xfrm>
+      </p:grpSpPr>
+      <p:sp>
+        <p:nvSpPr>
+          <p:cNvPr id="2" name="Title 1"/>
+          <p:cNvSpPr>
+            <a:spLocks noGrp="1"/>
+          </p:cNvSpPr>
+          <p:nvPr>
+            <p:ph type="title"/>
+          </p:nvPr>
+        </p:nvSpPr>
+        <p:spPr>
+          <a:xfrm>
+            <a:off x="0" y="0"/>
+            <a:ext cx="9144000" cy="582780"/>
+          </a:xfrm>
+        </p:spPr>
+        <p:txBody>
+          <a:bodyPr/>
+          <a:lstStyle/>
+          <a:p>
+            <a:pPr lvl="0" indent="0" marL="0">
+              <a:buNone/>
+            </a:pPr>
+            <a:r>
+              <a:rPr/>
+              <a:t>Before Thursday · Install R and Positron</a:t>
             </a:r>
           </a:p>
         </p:txBody>
@@ -4063,20 +4980,28 @@
             </a:pPr>
             <a:r>
               <a:rPr/>
-              <a:t>Download R - </a:t>
+              <a:t>Download </a:t>
+            </a:r>
+            <a:r>
+              <a:rPr b="1"/>
+              <a:t>R</a:t>
+            </a:r>
+            <a:r>
+              <a:rPr/>
+              <a:t> — </a:t>
             </a:r>
             <a:r>
               <a:rPr>
                 <a:hlinkClick r:id="rId2"/>
               </a:rPr>
-              <a:t>download here</a:t>
+              <a:t>cran.r-project.org</a:t>
             </a:r>
           </a:p>
           <a:p>
             <a:pPr lvl="1"/>
             <a:r>
               <a:rPr/>
-              <a:t>downloads to your computer - can you find it?</a:t>
+              <a:t>Installs to your computer — can you find it?</a:t>
             </a:r>
           </a:p>
           <a:p>
@@ -4085,20 +5010,72 @@
             </a:pPr>
             <a:r>
               <a:rPr/>
-              <a:t>Download Positron - </a:t>
+              <a:t>Download </a:t>
+            </a:r>
+            <a:r>
+              <a:rPr b="1"/>
+              <a:t>Positron</a:t>
+            </a:r>
+            <a:r>
+              <a:rPr/>
+              <a:t> — </a:t>
             </a:r>
             <a:r>
               <a:rPr>
                 <a:hlinkClick r:id="rId3"/>
               </a:rPr>
-              <a:t>download here</a:t>
+              <a:t>positron.posit.co</a:t>
             </a:r>
           </a:p>
           <a:p>
             <a:pPr lvl="1"/>
             <a:r>
               <a:rPr/>
-              <a:t>downloads to your computer - can you find it?</a:t>
+              <a:t>Install </a:t>
+            </a:r>
+            <a:r>
+              <a:rPr b="1"/>
+              <a:t>R first</a:t>
+            </a:r>
+            <a:r>
+              <a:rPr/>
+              <a:t>, then Positron — Positron needs to find R on your machine</a:t>
+            </a:r>
+          </a:p>
+          <a:p>
+            <a:pPr lvl="0" indent="0" marL="1270000">
+              <a:buNone/>
+            </a:pPr>
+            <a:r>
+              <a:rPr sz="2000" b="1"/>
+              <a:t>Important</a:t>
+            </a:r>
+          </a:p>
+          <a:p>
+            <a:pPr lvl="0" indent="0" marL="1270000">
+              <a:buNone/>
+            </a:pPr>
+            <a:r>
+              <a:rPr sz="2000" b="1"/>
+              <a:t>⚠️ Watch out!</a:t>
+            </a:r>
+          </a:p>
+          <a:p>
+            <a:pPr lvl="0" indent="0" marL="1270000">
+              <a:buNone/>
+            </a:pPr>
+            <a:r>
+              <a:rPr sz="2000"/>
+              <a:t>Install R first, then Positron. If you install Positron first, it may not find R automatically.</a:t>
+            </a:r>
+          </a:p>
+          <a:p>
+            <a:pPr lvl="0" indent="0" marL="0">
+              <a:buNone/>
+            </a:pPr>
+            <a:r>
+              <a:rPr i="1"/>
+              <a:t>See you Thursday — bring your laptop and the leaf data you entered in Excel.</a:t>
             </a:r>
           </a:p>
         </p:txBody>
@@ -4149,31 +5126,80 @@
               <a:buNone/>
             </a:pPr>
             <a:r>
+              <a:rPr/>
+              <a:t>Lecture 1 · Syllabus</a:t>
+            </a:r>
+          </a:p>
+        </p:txBody>
+      </p:sp>
+      <p:sp>
+        <p:nvSpPr>
+          <p:cNvPr id="3" name="Content Placeholder 2"/>
+          <p:cNvSpPr>
+            <a:spLocks noGrp="1"/>
+          </p:cNvSpPr>
+          <p:nvPr>
+            <p:ph idx="1"/>
+          </p:nvPr>
+        </p:nvSpPr>
+        <p:spPr/>
+        <p:txBody>
+          <a:bodyPr/>
+          <a:lstStyle/>
+          <a:p>
+            <a:pPr lvl="0"/>
+            <a:r>
+              <a:rPr/>
+              <a:t>The syllabus has </a:t>
+            </a:r>
+            <a:r>
               <a:rPr b="1"/>
-              <a:t>Lecture 1: Syllabus</a:t>
-            </a:r>
-          </a:p>
-        </p:txBody>
-      </p:sp>
-      <p:sp>
-        <p:nvSpPr>
-          <p:cNvPr id="3" name="Content Placeholder 2"/>
-          <p:cNvSpPr>
-            <a:spLocks noGrp="1"/>
-          </p:cNvSpPr>
-          <p:nvPr>
-            <p:ph idx="1"/>
-          </p:nvPr>
-        </p:nvSpPr>
-        <p:spPr/>
-        <p:txBody>
-          <a:bodyPr/>
-          <a:lstStyle/>
-          <a:p>
-            <a:pPr lvl="0"/>
-            <a:r>
-              <a:rPr/>
-              <a:t>Please look over the syllabus as it has all the details of the class and how it will run. It will serve as the tentative list of topics and what we will cover each day</a:t>
+              <a:t>all the details</a:t>
+            </a:r>
+            <a:r>
+              <a:rPr/>
+              <a:t> — topics, grading, policies, schedule</a:t>
+            </a:r>
+          </a:p>
+          <a:p>
+            <a:pPr lvl="0"/>
+            <a:r>
+              <a:rPr/>
+              <a:t>Read it before Thursday</a:t>
+            </a:r>
+          </a:p>
+          <a:p>
+            <a:pPr lvl="0"/>
+            <a:r>
+              <a:rPr/>
+              <a:t>It will evolve — check Canvas for the current version</a:t>
+            </a:r>
+          </a:p>
+          <a:p>
+            <a:pPr lvl="0" indent="0" marL="1270000">
+              <a:buNone/>
+            </a:pPr>
+            <a:r>
+              <a:rPr sz="2000" b="1"/>
+              <a:t>Note</a:t>
+            </a:r>
+          </a:p>
+          <a:p>
+            <a:pPr lvl="0" indent="0" marL="1270000">
+              <a:buNone/>
+            </a:pPr>
+            <a:r>
+              <a:rPr sz="2000" b="1"/>
+              <a:t>✅ Key idea</a:t>
+            </a:r>
+          </a:p>
+          <a:p>
+            <a:pPr lvl="0" indent="0" marL="1270000">
+              <a:buNone/>
+            </a:pPr>
+            <a:r>
+              <a:rPr sz="2000"/>
+              <a:t>The syllabus is the contract between us. If something is unclear, ask now — not at exam time.</a:t>
             </a:r>
           </a:p>
         </p:txBody>
@@ -4227,76 +5253,92 @@
               <a:buNone/>
             </a:pPr>
             <a:r>
+              <a:rPr/>
+              <a:t>Lecture 1 · Who am I?</a:t>
+            </a:r>
+          </a:p>
+        </p:txBody>
+      </p:sp>
+      <p:sp>
+        <p:nvSpPr>
+          <p:cNvPr id="3" name="Content Placeholder 2"/>
+          <p:cNvSpPr>
+            <a:spLocks noGrp="1"/>
+          </p:cNvSpPr>
+          <p:nvPr>
+            <p:ph idx="1" sz="half"/>
+          </p:nvPr>
+        </p:nvSpPr>
+        <p:spPr/>
+        <p:txBody>
+          <a:bodyPr/>
+          <a:lstStyle/>
+          <a:p>
+            <a:pPr lvl="0"/>
+            <a:r>
               <a:rPr b="1"/>
-              <a:t>Lecture 1:</a:t>
-            </a:r>
-            <a:r>
-              <a:rPr/>
-              <a:t> Who am I?</a:t>
-            </a:r>
-          </a:p>
-        </p:txBody>
-      </p:sp>
-      <p:sp>
-        <p:nvSpPr>
-          <p:cNvPr id="3" name="Content Placeholder 2"/>
-          <p:cNvSpPr>
-            <a:spLocks noGrp="1"/>
-          </p:cNvSpPr>
-          <p:nvPr>
-            <p:ph idx="1" sz="half"/>
-          </p:nvPr>
-        </p:nvSpPr>
-        <p:spPr/>
-        <p:txBody>
-          <a:bodyPr/>
-          <a:lstStyle/>
-          <a:p>
-            <a:pPr lvl="0" indent="0" marL="0">
-              <a:spcBef>
-                <a:spcPts val="3000"/>
-              </a:spcBef>
-              <a:buNone/>
-            </a:pPr>
-            <a:r>
-              <a:rPr b="1"/>
-              <a:t>The objectives:</a:t>
-            </a:r>
-          </a:p>
-          <a:p>
-            <a:pPr lvl="0"/>
-            <a:r>
-              <a:rPr/>
-              <a:t>Bill Perry - </a:t>
-            </a:r>
-            <a:r>
-              <a:rPr b="1"/>
-              <a:t>Bill</a:t>
-            </a:r>
-            <a:r>
-              <a:rPr/>
-              <a:t> or Dr. Perry</a:t>
-            </a:r>
-          </a:p>
-          <a:p>
-            <a:pPr lvl="0"/>
-            <a:r>
-              <a:rPr/>
-              <a:t>Office is in SSB 13</a:t>
-            </a:r>
-          </a:p>
-          <a:p>
-            <a:pPr lvl="0"/>
-            <a:r>
-              <a:rPr/>
-              <a:t>Phone 218-726-8145</a:t>
-            </a:r>
-          </a:p>
-          <a:p>
-            <a:pPr lvl="0"/>
-            <a:r>
-              <a:rPr/>
-              <a:t>Email is wlperry@d.umn.edu</a:t>
+              <a:t>Bill Perry</a:t>
+            </a:r>
+            <a:r>
+              <a:rPr/>
+              <a:t> — call me Bill or Dr. Perry</a:t>
+            </a:r>
+          </a:p>
+          <a:p>
+            <a:pPr lvl="0"/>
+            <a:r>
+              <a:rPr/>
+              <a:t>Office: Swenson Science Building 13</a:t>
+            </a:r>
+          </a:p>
+          <a:p>
+            <a:pPr lvl="0"/>
+            <a:r>
+              <a:rPr/>
+              <a:t>Phone: 218-726-8145</a:t>
+            </a:r>
+          </a:p>
+          <a:p>
+            <a:pPr lvl="0"/>
+            <a:r>
+              <a:rPr/>
+              <a:t>Email: wlperry@d.umn.edu</a:t>
+            </a:r>
+          </a:p>
+          <a:p>
+            <a:pPr lvl="0"/>
+            <a:r>
+              <a:rPr/>
+              <a:t>Drop-in hours: Monday 12:15–1:15, Tuesday 2–3 (tentative)</a:t>
+            </a:r>
+          </a:p>
+          <a:p>
+            <a:pPr lvl="0"/>
+            <a:r>
+              <a:rPr/>
+              <a:t>Lab: SSB 170</a:t>
+            </a:r>
+          </a:p>
+          <a:p>
+            <a:pPr lvl="0" indent="0" marL="1270000">
+              <a:buNone/>
+            </a:pPr>
+            <a:r>
+              <a:rPr sz="2000" b="1"/>
+              <a:t>Tip</a:t>
+            </a:r>
+          </a:p>
+          <a:p>
+            <a:pPr lvl="0" indent="0" marL="1270000">
+              <a:buNone/>
+            </a:pPr>
+            <a:r>
+              <a:rPr sz="2000" b="1"/>
+              <a:t>Best way to reach me:</a:t>
+            </a:r>
+            <a:r>
+              <a:rPr sz="2000"/>
+              <a:t> email or drop in. If I am in the lab I am usually around.</a:t>
             </a:r>
           </a:p>
         </p:txBody>
@@ -4378,7 +5420,7 @@
             </a:pPr>
             <a:r>
               <a:rPr/>
-              <a:t>Lecture 1: My goals</a:t>
+              <a:t>Lecture 1 · My goals for this course</a:t>
             </a:r>
           </a:p>
         </p:txBody>
@@ -4401,49 +5443,123 @@
             <a:pPr lvl="0"/>
             <a:r>
               <a:rPr/>
-              <a:t>Help you learn the tools to organize and present data from potentially very large data sets</a:t>
-            </a:r>
-          </a:p>
-          <a:p>
-            <a:pPr lvl="0"/>
-            <a:r>
-              <a:rPr/>
-              <a:t>How to use basic excel for some tasks</a:t>
-            </a:r>
-          </a:p>
-          <a:p>
-            <a:pPr lvl="0"/>
-            <a:r>
-              <a:rPr/>
-              <a:t>How to use R - a coding language - to work with data and graphics</a:t>
-            </a:r>
-          </a:p>
-          <a:p>
-            <a:pPr lvl="0"/>
-            <a:r>
-              <a:rPr/>
-              <a:t>How do we organize, clean, summarize, and view the data? The pipeline…</a:t>
-            </a:r>
-          </a:p>
-          <a:p>
-            <a:pPr lvl="0"/>
-            <a:r>
-              <a:rPr/>
-              <a:t>How to formulate hypotheses</a:t>
-            </a:r>
-          </a:p>
-          <a:p>
-            <a:pPr lvl="0"/>
-            <a:r>
-              <a:rPr/>
-              <a:t>How do we use statistics to test our hypotheses</a:t>
-            </a:r>
-          </a:p>
-          <a:p>
-            <a:pPr lvl="0"/>
-            <a:r>
-              <a:rPr/>
-              <a:t>How to interpret what the data is telling us using statistics</a:t>
+              <a:t>Help you learn the tools to </a:t>
+            </a:r>
+            <a:r>
+              <a:rPr b="1"/>
+              <a:t>organize and present data</a:t>
+            </a:r>
+            <a:r>
+              <a:rPr/>
+              <a:t> from potentially very large datasets</a:t>
+            </a:r>
+          </a:p>
+          <a:p>
+            <a:pPr lvl="0"/>
+            <a:r>
+              <a:rPr/>
+              <a:t>How to use </a:t>
+            </a:r>
+            <a:r>
+              <a:rPr b="1"/>
+              <a:t>Excel</a:t>
+            </a:r>
+            <a:r>
+              <a:rPr/>
+              <a:t> for some tasks — and when to stop using it</a:t>
+            </a:r>
+          </a:p>
+          <a:p>
+            <a:pPr lvl="0"/>
+            <a:r>
+              <a:rPr/>
+              <a:t>How to use </a:t>
+            </a:r>
+            <a:r>
+              <a:rPr b="1"/>
+              <a:t>R</a:t>
+            </a:r>
+            <a:r>
+              <a:rPr/>
+              <a:t> — a coding language — to work with data and graphics</a:t>
+            </a:r>
+          </a:p>
+          <a:p>
+            <a:pPr lvl="0"/>
+            <a:r>
+              <a:rPr/>
+              <a:t>How to </a:t>
+            </a:r>
+            <a:r>
+              <a:rPr b="1"/>
+              <a:t>organize, clean, summarize, and visualize</a:t>
+            </a:r>
+            <a:r>
+              <a:rPr/>
+              <a:t> data — the pipeline</a:t>
+            </a:r>
+          </a:p>
+          <a:p>
+            <a:pPr lvl="0"/>
+            <a:r>
+              <a:rPr/>
+              <a:t>How to formulate and test </a:t>
+            </a:r>
+            <a:r>
+              <a:rPr b="1"/>
+              <a:t>hypotheses</a:t>
+            </a:r>
+          </a:p>
+          <a:p>
+            <a:pPr lvl="0"/>
+            <a:r>
+              <a:rPr/>
+              <a:t>How to use </a:t>
+            </a:r>
+            <a:r>
+              <a:rPr b="1"/>
+              <a:t>statistics</a:t>
+            </a:r>
+            <a:r>
+              <a:rPr/>
+              <a:t> to test those hypotheses</a:t>
+            </a:r>
+          </a:p>
+          <a:p>
+            <a:pPr lvl="0"/>
+            <a:r>
+              <a:rPr/>
+              <a:t>How to </a:t>
+            </a:r>
+            <a:r>
+              <a:rPr b="1"/>
+              <a:t>interpret</a:t>
+            </a:r>
+            <a:r>
+              <a:rPr/>
+              <a:t> what the data is telling us</a:t>
+            </a:r>
+          </a:p>
+          <a:p>
+            <a:pPr lvl="0" indent="0" marL="1270000">
+              <a:buNone/>
+            </a:pPr>
+            <a:r>
+              <a:rPr sz="2000" b="1"/>
+              <a:t>Note</a:t>
+            </a:r>
+          </a:p>
+          <a:p>
+            <a:pPr lvl="0" indent="0" marL="1270000">
+              <a:buNone/>
+            </a:pPr>
+            <a:r>
+              <a:rPr sz="2000" b="1"/>
+              <a:t>The pipeline:</a:t>
+            </a:r>
+            <a:r>
+              <a:rPr sz="2000"/>
+              <a:t> raw data → clean → summarize → visualize → test → report This course teaches every step.</a:t>
             </a:r>
           </a:p>
         </p:txBody>
@@ -4483,8 +5599,11 @@
         <p:spPr>
           <a:xfrm>
             <a:off x="0" y="0"/>
-            <a:ext cx="9144000" cy="582780"/>
+            <a:ext cx="9144000" cy="602780"/>
           </a:xfrm>
+          <a:solidFill>
+            <a:srgbClr val="1A1A2E"/>
+          </a:solidFill>
         </p:spPr>
         <p:txBody>
           <a:bodyPr/>
@@ -4495,7 +5614,7 @@
             </a:pPr>
             <a:r>
               <a:rPr/>
-              <a:t>Lecture 1: My expectations</a:t>
+              <a:t>Lecture 1 · My expectations</a:t>
             </a:r>
           </a:p>
         </p:txBody>
@@ -4507,7 +5626,7 @@
             <a:spLocks noGrp="1"/>
           </p:cNvSpPr>
           <p:nvPr>
-            <p:ph idx="1"/>
+            <p:ph idx="1" sz="half"/>
           </p:nvPr>
         </p:nvSpPr>
         <p:spPr/>
@@ -4520,6 +5639,10 @@
               <a:rPr b="1"/>
               <a:t>Communication</a:t>
             </a:r>
+            <a:r>
+              <a:rPr/>
+              <a:t> — ask questions in class, in office hours, by email</a:t>
+            </a:r>
           </a:p>
           <a:p>
             <a:pPr lvl="0"/>
@@ -4527,6 +5650,10 @@
               <a:rPr b="1"/>
               <a:t>Practice</a:t>
             </a:r>
+            <a:r>
+              <a:rPr/>
+              <a:t> — the only way to learn to code is to write code</a:t>
+            </a:r>
           </a:p>
           <a:p>
             <a:pPr lvl="0"/>
@@ -4534,12 +5661,123 @@
               <a:rPr b="1"/>
               <a:t>Failure</a:t>
             </a:r>
+            <a:r>
+              <a:rPr/>
+              <a:t> — every error message is information; celebrate finding bugs</a:t>
+            </a:r>
           </a:p>
           <a:p>
             <a:pPr lvl="0"/>
             <a:r>
               <a:rPr b="1"/>
-              <a:t>Learn to correct and troubleshoot</a:t>
+              <a:t>Learn to troubleshoot</a:t>
+            </a:r>
+            <a:r>
+              <a:rPr/>
+              <a:t> — reading error messages is a skill we will practice</a:t>
+            </a:r>
+          </a:p>
+          <a:p>
+            <a:pPr lvl="0" indent="0" marL="1270000">
+              <a:buNone/>
+            </a:pPr>
+            <a:r>
+              <a:rPr sz="2000" b="1"/>
+              <a:t>Important</a:t>
+            </a:r>
+          </a:p>
+          <a:p>
+            <a:pPr lvl="0" indent="0" marL="1270000">
+              <a:buNone/>
+            </a:pPr>
+            <a:r>
+              <a:rPr sz="2000" b="1"/>
+              <a:t>Getting stuck is not failing — it is the job.</a:t>
+            </a:r>
+          </a:p>
+          <a:p>
+            <a:pPr lvl="0" indent="0" marL="1270000">
+              <a:buNone/>
+            </a:pPr>
+            <a:r>
+              <a:rPr sz="2000"/>
+              <a:t>Every working data scientist searches Google for error messages every single day.</a:t>
+            </a:r>
+          </a:p>
+        </p:txBody>
+      </p:sp>
+      <p:sp>
+        <p:nvSpPr>
+          <p:cNvPr id="4" name="Content Placeholder 3"/>
+          <p:cNvSpPr>
+            <a:spLocks noGrp="1"/>
+          </p:cNvSpPr>
+          <p:nvPr>
+            <p:ph idx="2" sz="half"/>
+          </p:nvPr>
+        </p:nvSpPr>
+        <p:spPr/>
+        <p:txBody>
+          <a:bodyPr/>
+          <a:lstStyle/>
+          <a:p>
+            <a:pPr lvl="0" indent="0" marL="0">
+              <a:buNone/>
+            </a:pPr>
+            <a:r>
+              <a:rPr b="1"/>
+              <a:t>What I will do:</a:t>
+            </a:r>
+          </a:p>
+          <a:p>
+            <a:pPr lvl="0"/>
+            <a:r>
+              <a:rPr/>
+              <a:t>Provide clear examples</a:t>
+            </a:r>
+          </a:p>
+          <a:p>
+            <a:pPr lvl="0"/>
+            <a:r>
+              <a:rPr/>
+              <a:t>Walk through code line by line</a:t>
+            </a:r>
+          </a:p>
+          <a:p>
+            <a:pPr lvl="0"/>
+            <a:r>
+              <a:rPr/>
+              <a:t>Give you real datasets to work with</a:t>
+            </a:r>
+          </a:p>
+          <a:p>
+            <a:pPr lvl="0" indent="0" marL="0">
+              <a:buNone/>
+            </a:pPr>
+            <a:r>
+              <a:rPr b="1"/>
+              <a:t>What you need to do:</a:t>
+            </a:r>
+          </a:p>
+          <a:p>
+            <a:pPr lvl="0"/>
+            <a:r>
+              <a:rPr/>
+              <a:t>Type the code yourself (do not copy-paste)</a:t>
+            </a:r>
+          </a:p>
+          <a:p>
+            <a:pPr lvl="0"/>
+            <a:r>
+              <a:rPr/>
+              <a:t>Run it, break it, fix it</a:t>
+            </a:r>
+          </a:p>
+          <a:p>
+            <a:pPr lvl="0"/>
+            <a:r>
+              <a:rPr/>
+              <a:t>Bring questions to class</a:t>
             </a:r>
           </a:p>
         </p:txBody>
@@ -4579,8 +5817,11 @@
         <p:spPr>
           <a:xfrm>
             <a:off x="0" y="0"/>
-            <a:ext cx="9144000" cy="582780"/>
+            <a:ext cx="9144000" cy="602780"/>
           </a:xfrm>
+          <a:solidFill>
+            <a:srgbClr val="1A1A2E"/>
+          </a:solidFill>
         </p:spPr>
         <p:txBody>
           <a:bodyPr/>
@@ -4590,20 +5831,110 @@
               <a:buNone/>
             </a:pPr>
             <a:r>
+              <a:rPr/>
+              <a:t>Lecture 1 · Science</a:t>
+            </a:r>
+          </a:p>
+        </p:txBody>
+      </p:sp>
+      <p:sp>
+        <p:nvSpPr>
+          <p:cNvPr id="3" name="Content Placeholder 2"/>
+          <p:cNvSpPr>
+            <a:spLocks noGrp="1"/>
+          </p:cNvSpPr>
+          <p:nvPr>
+            <p:ph idx="1" sz="half"/>
+          </p:nvPr>
+        </p:nvSpPr>
+        <p:spPr/>
+        <p:txBody>
+          <a:bodyPr/>
+          <a:lstStyle/>
+          <a:p>
+            <a:pPr lvl="0"/>
+            <a:r>
+              <a:rPr/>
+              <a:t>Science is a way to </a:t>
+            </a:r>
+            <a:r>
               <a:rPr b="1"/>
-              <a:t>Lecture 1: Science</a:t>
-            </a:r>
-          </a:p>
-        </p:txBody>
-      </p:sp>
-      <p:sp>
-        <p:nvSpPr>
-          <p:cNvPr id="3" name="Content Placeholder 2"/>
-          <p:cNvSpPr>
-            <a:spLocks noGrp="1"/>
-          </p:cNvSpPr>
-          <p:nvPr>
-            <p:ph idx="1"/>
+              <a:t>acquire, organize, and apply knowledge</a:t>
+            </a:r>
+          </a:p>
+          <a:p>
+            <a:pPr lvl="0"/>
+            <a:r>
+              <a:rPr/>
+              <a:t>We make </a:t>
+            </a:r>
+            <a:r>
+              <a:rPr b="1"/>
+              <a:t>predictions</a:t>
+            </a:r>
+            <a:r>
+              <a:rPr/>
+              <a:t> and test them with a </a:t>
+            </a:r>
+            <a:r>
+              <a:rPr b="1"/>
+              <a:t>falsifiable approach</a:t>
+            </a:r>
+            <a:r>
+              <a:rPr/>
+              <a:t> — statistics</a:t>
+            </a:r>
+          </a:p>
+          <a:p>
+            <a:pPr lvl="0"/>
+            <a:r>
+              <a:rPr/>
+              <a:t>Explanations that </a:t>
+            </a:r>
+            <a:r>
+              <a:rPr b="1"/>
+              <a:t>cannot be tested or falsified</a:t>
+            </a:r>
+            <a:r>
+              <a:rPr/>
+              <a:t> are not science</a:t>
+            </a:r>
+          </a:p>
+          <a:p>
+            <a:pPr lvl="0" indent="0" marL="0">
+              <a:buNone/>
+            </a:pPr>
+            <a:r>
+              <a:rPr b="1"/>
+              <a:t>Example:</a:t>
+            </a:r>
+            <a:r>
+              <a:rPr/>
+              <a:t> - “Leaves on the shady side are bigger” — </a:t>
+            </a:r>
+            <a:r>
+              <a:rPr b="1"/>
+              <a:t>testable</a:t>
+            </a:r>
+            <a:r>
+              <a:rPr/>
+              <a:t> - “The forest has a spirit that controls leaf size” — </a:t>
+            </a:r>
+            <a:r>
+              <a:rPr b="1"/>
+              <a:t>not testable</a:t>
+            </a:r>
+          </a:p>
+        </p:txBody>
+      </p:sp>
+      <p:sp>
+        <p:nvSpPr>
+          <p:cNvPr id="4" name="Content Placeholder 3"/>
+          <p:cNvSpPr>
+            <a:spLocks noGrp="1"/>
+          </p:cNvSpPr>
+          <p:nvPr>
+            <p:ph idx="2" sz="half"/>
           </p:nvPr>
         </p:nvSpPr>
         <p:spPr/>
@@ -4611,24 +5942,43 @@
           <a:bodyPr/>
           <a:lstStyle/>
           <a:p>
-            <a:pPr lvl="0"/>
-            <a:r>
-              <a:rPr/>
-              <a:t>Way to acquire knowledge, organize it and apply it back to the real world</a:t>
-            </a:r>
-          </a:p>
-          <a:p>
-            <a:pPr lvl="0"/>
-            <a:r>
-              <a:rPr/>
-              <a:t>Make predictions and testing these predictions using a falsifiable approach - statistics</a:t>
-            </a:r>
-          </a:p>
-          <a:p>
-            <a:pPr lvl="0"/>
-            <a:r>
-              <a:rPr/>
-              <a:t>Explanations that cannot be falsified are not science</a:t>
+            <a:pPr lvl="0" indent="0" marL="1270000">
+              <a:buNone/>
+            </a:pPr>
+            <a:r>
+              <a:rPr sz="2000" b="1"/>
+              <a:t>Note</a:t>
+            </a:r>
+          </a:p>
+          <a:p>
+            <a:pPr lvl="0" indent="0" marL="1270000">
+              <a:buNone/>
+            </a:pPr>
+            <a:r>
+              <a:rPr sz="2000" b="1"/>
+              <a:t>📖 New vocabulary</a:t>
+            </a:r>
+          </a:p>
+          <a:p>
+            <a:pPr lvl="0" indent="0" marL="1270000">
+              <a:buNone/>
+            </a:pPr>
+            <a:r>
+              <a:rPr sz="2000" b="1"/>
+              <a:t>Falsifiable</a:t>
+            </a:r>
+            <a:r>
+              <a:rPr sz="2000"/>
+              <a:t> = a prediction that could, in principle, be shown to be wrong.</a:t>
+            </a:r>
+          </a:p>
+          <a:p>
+            <a:pPr lvl="0" indent="0" marL="1270000">
+              <a:buNone/>
+            </a:pPr>
+            <a:r>
+              <a:rPr sz="2000"/>
+              <a:t>A good hypothesis is one you could prove false with the right data.</a:t>
             </a:r>
           </a:p>
         </p:txBody>
@@ -4680,7 +6030,7 @@
             </a:pPr>
             <a:r>
               <a:rPr/>
-              <a:t>Today… real world data science</a:t>
+              <a:t>Today · Real-world data science</a:t>
             </a:r>
           </a:p>
         </p:txBody>
@@ -4703,39 +6053,75 @@
             <a:pPr lvl="0"/>
             <a:r>
               <a:rPr/>
-              <a:t>talking about data science is </a:t>
+              <a:t>Talking about data science is </a:t>
             </a:r>
             <a:r>
               <a:rPr b="1"/>
-              <a:t>SUPER BORING</a:t>
-            </a:r>
-          </a:p>
-          <a:p>
-            <a:pPr lvl="1"/>
-            <a:r>
-              <a:rPr/>
-              <a:t>How do you tell a story with data using math - statistics - code</a:t>
-            </a:r>
-          </a:p>
-          <a:p>
-            <a:pPr lvl="0"/>
-            <a:r>
-              <a:rPr/>
-              <a:t>This lecture and the next will be about how to work with data from the start</a:t>
-            </a:r>
-          </a:p>
-          <a:p>
-            <a:pPr lvl="0"/>
-            <a:r>
-              <a:rPr/>
-              <a:t>Your task will be to collect data - organize it - get it into a spreadsheet</a:t>
-            </a:r>
-          </a:p>
-          <a:p>
-            <a:pPr lvl="0"/>
-            <a:r>
-              <a:rPr/>
-              <a:t>Develop meta data</a:t>
+              <a:t>super boring</a:t>
+            </a:r>
+          </a:p>
+          <a:p>
+            <a:pPr lvl="0"/>
+            <a:r>
+              <a:rPr/>
+              <a:t>The only way to learn it is to </a:t>
+            </a:r>
+            <a:r>
+              <a:rPr b="1"/>
+              <a:t>do it</a:t>
+            </a:r>
+            <a:r>
+              <a:rPr/>
+              <a:t> — collect data, enter it, analyze it</a:t>
+            </a:r>
+          </a:p>
+          <a:p>
+            <a:pPr lvl="0"/>
+            <a:r>
+              <a:rPr/>
+              <a:t>This lecture and the next will be about how to work with data from the </a:t>
+            </a:r>
+            <a:r>
+              <a:rPr b="1"/>
+              <a:t>very start</a:t>
+            </a:r>
+          </a:p>
+          <a:p>
+            <a:pPr lvl="0"/>
+            <a:r>
+              <a:rPr/>
+              <a:t>Your task: </a:t>
+            </a:r>
+            <a:r>
+              <a:rPr b="1"/>
+              <a:t>collect data → organize it → enter it into a spreadsheet → develop metadata</a:t>
+            </a:r>
+          </a:p>
+          <a:p>
+            <a:pPr lvl="0" indent="0" marL="1270000">
+              <a:buNone/>
+            </a:pPr>
+            <a:r>
+              <a:rPr sz="2000" b="1"/>
+              <a:t>Tip</a:t>
+            </a:r>
+          </a:p>
+          <a:p>
+            <a:pPr lvl="0" indent="0" marL="1270000">
+              <a:buNone/>
+            </a:pPr>
+            <a:r>
+              <a:rPr sz="2000" b="1"/>
+              <a:t>🖐 Try it yourself</a:t>
+            </a:r>
+          </a:p>
+          <a:p>
+            <a:pPr lvl="0" indent="0" marL="1270000">
+              <a:buNone/>
+            </a:pPr>
+            <a:r>
+              <a:rPr sz="2000"/>
+              <a:t>We are going to go outside, collect leaves, and build our first dataset today. That dataset will follow us for the first half of the course.</a:t>
             </a:r>
           </a:p>
         </p:txBody>
@@ -4775,8 +6161,11 @@
         <p:spPr>
           <a:xfrm>
             <a:off x="0" y="0"/>
-            <a:ext cx="9144000" cy="582780"/>
+            <a:ext cx="9144000" cy="602780"/>
           </a:xfrm>
+          <a:solidFill>
+            <a:srgbClr val="1A1A2E"/>
+          </a:solidFill>
         </p:spPr>
         <p:txBody>
           <a:bodyPr/>
@@ -4799,7 +6188,7 @@
             <a:spLocks noGrp="1"/>
           </p:cNvSpPr>
           <p:nvPr>
-            <p:ph idx="1"/>
+            <p:ph idx="1" sz="half"/>
           </p:nvPr>
         </p:nvSpPr>
         <p:spPr/>
@@ -4810,14 +6199,26 @@
             <a:pPr lvl="0"/>
             <a:r>
               <a:rPr/>
-              <a:t>We are going to measure something</a:t>
-            </a:r>
-          </a:p>
-          <a:p>
-            <a:pPr lvl="0"/>
-            <a:r>
-              <a:rPr/>
-              <a:t>My suggestion is leaf mass and surface area from a tree on the sunny side versus shady side?</a:t>
+              <a:t>We are going to </a:t>
+            </a:r>
+            <a:r>
+              <a:rPr b="1"/>
+              <a:t>measure something in nature</a:t>
+            </a:r>
+          </a:p>
+          <a:p>
+            <a:pPr lvl="0"/>
+            <a:r>
+              <a:rPr/>
+              <a:t>Suggestion: leaf mass and surface area from the </a:t>
+            </a:r>
+            <a:r>
+              <a:rPr b="1"/>
+              <a:t>sunny side vs. shady side</a:t>
+            </a:r>
+            <a:r>
+              <a:rPr/>
+              <a:t> of a tree</a:t>
             </a:r>
           </a:p>
           <a:p>
@@ -4828,17 +6229,99 @@
             </a:r>
           </a:p>
           <a:p>
-            <a:pPr lvl="1"/>
-            <a:r>
-              <a:rPr/>
-              <a:t>What is the Null Hypothesis</a:t>
-            </a:r>
-          </a:p>
-          <a:p>
-            <a:pPr lvl="1"/>
-            <a:r>
-              <a:rPr/>
-              <a:t>What is the Alternate Hypothesis</a:t>
+            <a:pPr lvl="0" indent="0" marL="0">
+              <a:buNone/>
+            </a:pPr>
+            <a:r>
+              <a:rPr b="1"/>
+              <a:t>The null hypothesis (H₀):</a:t>
+            </a:r>
+          </a:p>
+          <a:p>
+            <a:pPr lvl="0" indent="0" marL="0">
+              <a:buNone/>
+            </a:pPr>
+            <a:r>
+              <a:rPr i="1"/>
+              <a:t>There is no difference in leaf size or shape between the two sides of a tree.</a:t>
+            </a:r>
+          </a:p>
+          <a:p>
+            <a:pPr lvl="0" indent="0" marL="0">
+              <a:buNone/>
+            </a:pPr>
+            <a:r>
+              <a:rPr b="1"/>
+              <a:t>The alternate hypothesis (Hₐ):</a:t>
+            </a:r>
+          </a:p>
+          <a:p>
+            <a:pPr lvl="0" indent="0" marL="0">
+              <a:buNone/>
+            </a:pPr>
+            <a:r>
+              <a:rPr i="1"/>
+              <a:t>Leaf size differs between the sunny and shady sides.</a:t>
+            </a:r>
+          </a:p>
+        </p:txBody>
+      </p:sp>
+      <p:sp>
+        <p:nvSpPr>
+          <p:cNvPr id="4" name="Content Placeholder 3"/>
+          <p:cNvSpPr>
+            <a:spLocks noGrp="1"/>
+          </p:cNvSpPr>
+          <p:nvPr>
+            <p:ph idx="2" sz="half"/>
+          </p:nvPr>
+        </p:nvSpPr>
+        <p:spPr/>
+        <p:txBody>
+          <a:bodyPr/>
+          <a:lstStyle/>
+          <a:p>
+            <a:pPr lvl="0" indent="0" marL="1270000">
+              <a:buNone/>
+            </a:pPr>
+            <a:r>
+              <a:rPr sz="2000" b="1"/>
+              <a:t>Note</a:t>
+            </a:r>
+          </a:p>
+          <a:p>
+            <a:pPr lvl="0" indent="0" marL="1270000">
+              <a:buNone/>
+            </a:pPr>
+            <a:r>
+              <a:rPr sz="2000" b="1"/>
+              <a:t>📖 New vocabulary</a:t>
+            </a:r>
+          </a:p>
+          <a:p>
+            <a:pPr lvl="0" indent="0" marL="1270000">
+              <a:buNone/>
+            </a:pPr>
+            <a:r>
+              <a:rPr sz="2000" b="1"/>
+              <a:t>Null hypothesis (H₀)</a:t>
+            </a:r>
+            <a:r>
+              <a:rPr sz="2000"/>
+              <a:t> — the “nothing is happening” claim. Statistics will tell us whether the data are consistent with this or not.</a:t>
+            </a:r>
+          </a:p>
+          <a:p>
+            <a:pPr lvl="0" indent="0" marL="1270000">
+              <a:buNone/>
+            </a:pPr>
+            <a:r>
+              <a:rPr sz="2000" b="1"/>
+              <a:t>Alternate hypothesis (Hₐ)</a:t>
+            </a:r>
+            <a:r>
+              <a:rPr sz="2000"/>
+              <a:t> — the claim we think might be true.</a:t>
             </a:r>
           </a:p>
         </p:txBody>
@@ -4913,28 +6396,99 @@
             <a:pPr lvl="0"/>
             <a:r>
               <a:rPr/>
-              <a:t>Does the sunny and shady sides of trees differ due to light?</a:t>
-            </a:r>
-          </a:p>
-          <a:p>
-            <a:pPr lvl="0"/>
-            <a:r>
-              <a:rPr/>
-              <a:t>What might we predict versus hypothesize</a:t>
-            </a:r>
-          </a:p>
-          <a:p>
-            <a:pPr lvl="1"/>
-            <a:r>
-              <a:rPr/>
-              <a:t>Predict</a:t>
-            </a:r>
-          </a:p>
-          <a:p>
-            <a:pPr lvl="1"/>
-            <a:r>
-              <a:rPr/>
-              <a:t>Hypothesize</a:t>
+              <a:t>Does the sunny side vs. shady side of a tree differ due to light?</a:t>
+            </a:r>
+          </a:p>
+          <a:p>
+            <a:pPr lvl="0"/>
+            <a:r>
+              <a:rPr b="1"/>
+              <a:t>Predict:</a:t>
+            </a:r>
+            <a:r>
+              <a:rPr/>
+              <a:t> what do you think will happen before we collect any data?</a:t>
+            </a:r>
+          </a:p>
+          <a:p>
+            <a:pPr lvl="1" indent="0" marL="342900">
+              <a:buNone/>
+            </a:pPr>
+            <a:r>
+              <a:rPr i="1"/>
+              <a:t>Your prediction:</a:t>
+            </a:r>
+          </a:p>
+          <a:p>
+            <a:pPr lvl="0"/>
+            <a:r>
+              <a:rPr b="1"/>
+              <a:t>Hypothesize:</a:t>
+            </a:r>
+            <a:r>
+              <a:rPr/>
+              <a:t> what is the formal testable statement?</a:t>
+            </a:r>
+          </a:p>
+          <a:p>
+            <a:pPr lvl="1" indent="0" marL="342900">
+              <a:buNone/>
+            </a:pPr>
+            <a:r>
+              <a:rPr i="1"/>
+              <a:t>Your null hypothesis:</a:t>
+            </a:r>
+          </a:p>
+          <a:p>
+            <a:pPr lvl="1" indent="0" marL="342900">
+              <a:buNone/>
+            </a:pPr>
+            <a:r>
+              <a:rPr i="1"/>
+              <a:t>Your alternate hypothesis:</a:t>
+            </a:r>
+          </a:p>
+          <a:p>
+            <a:pPr lvl="0" indent="0" marL="1270000">
+              <a:buNone/>
+            </a:pPr>
+            <a:r>
+              <a:rPr sz="2000" b="1"/>
+              <a:t>Tip</a:t>
+            </a:r>
+          </a:p>
+          <a:p>
+            <a:pPr lvl="0" indent="0" marL="1270000">
+              <a:buNone/>
+            </a:pPr>
+            <a:r>
+              <a:rPr sz="2000" b="1"/>
+              <a:t>Key distinction</a:t>
+            </a:r>
+          </a:p>
+          <a:p>
+            <a:pPr lvl="0" indent="0" marL="1270000">
+              <a:buNone/>
+            </a:pPr>
+            <a:r>
+              <a:rPr sz="2000"/>
+              <a:t>A </a:t>
+            </a:r>
+            <a:r>
+              <a:rPr sz="2000" b="1"/>
+              <a:t>prediction</a:t>
+            </a:r>
+            <a:r>
+              <a:rPr sz="2000"/>
+              <a:t> says what you think will happen. A </a:t>
+            </a:r>
+            <a:r>
+              <a:rPr sz="2000" b="1"/>
+              <a:t>hypothesis</a:t>
+            </a:r>
+            <a:r>
+              <a:rPr sz="2000"/>
+              <a:t> is a formal statement that can be accepted or rejected with data.</a:t>
             </a:r>
           </a:p>
         </p:txBody>

</xml_diff>

<commit_message>
ok fixed up to 6 wiht all homeworks and activites and such
</commit_message>
<xml_diff>
--- a/docs/lectures/lecture_01/01_lecture_powerpoint.pptx
+++ b/docs/lectures/lecture_01/01_lecture_powerpoint.pptx
@@ -3356,7 +3356,7 @@
             </a:pPr>
             <a:r>
               <a:rPr/>
-              <a:t>2026-06-28</a:t>
+              <a:t>2026-06-30</a:t>
             </a:r>
           </a:p>
         </p:txBody>
@@ -3446,7 +3446,14 @@
             <a:pPr lvl="1"/>
             <a:r>
               <a:rPr/>
-              <a:t>YES? NO? — Discuss</a:t>
+              <a:t>YES? or no NO?</a:t>
+            </a:r>
+          </a:p>
+          <a:p>
+            <a:pPr lvl="1"/>
+            <a:r>
+              <a:rPr b="1"/>
+              <a:t>Discuss</a:t>
             </a:r>
           </a:p>
           <a:p>
@@ -3689,9 +3696,7 @@
             </a:r>
           </a:p>
           <a:p>
-            <a:pPr lvl="0" indent="0" marL="1270000">
-              <a:buNone/>
-            </a:pPr>
+            <a:pPr lvl="0"/>
             <a:r>
               <a:rPr sz="2000" b="1"/>
               <a:t>Dependent variable</a:t>
@@ -3702,9 +3707,7 @@
             </a:r>
           </a:p>
           <a:p>
-            <a:pPr lvl="0" indent="0" marL="1270000">
-              <a:buNone/>
-            </a:pPr>
+            <a:pPr lvl="0"/>
             <a:r>
               <a:rPr sz="2000" b="1"/>
               <a:t>Independent variable</a:t>
@@ -3715,9 +3718,7 @@
             </a:r>
           </a:p>
           <a:p>
-            <a:pPr lvl="0" indent="0" marL="1270000">
-              <a:buNone/>
-            </a:pPr>
+            <a:pPr lvl="1"/>
             <a:r>
               <a:rPr sz="2000"/>
               <a:t>In a graph: Y goes on the vertical axis, X goes on the horizontal axis.</a:t>
@@ -3772,7 +3773,7 @@
             </a:pPr>
             <a:r>
               <a:rPr/>
-              <a:t>Each group needs to collect at least 3 pairs of leaves</a:t>
+              <a:t>Each group needs to collect at least 2 pairs of leaves</a:t>
             </a:r>
           </a:p>
         </p:txBody>
@@ -3833,7 +3834,11 @@
             <a:pPr lvl="0"/>
             <a:r>
               <a:rPr/>
-              <a:t>Standardize your collection:</a:t>
+              <a:t>Standardize your collection: </a:t>
+            </a:r>
+            <a:r>
+              <a:rPr b="1"/>
+              <a:t>(DISCUSS AND FIGURE IT OUT BY YOURSELVES)</a:t>
             </a:r>
           </a:p>
           <a:p>
@@ -3881,15 +3886,16 @@
             </a:pPr>
             <a:r>
               <a:rPr sz="2000"/>
-              <a:t>If everyone collects differently (different heights, different leaf ages), we cannot combine our data. Agree on the rules </a:t>
-            </a:r>
+              <a:t>If everyone collects differently (different heights, different leaf ages), we cannot combine our data.</a:t>
+            </a:r>
+          </a:p>
+          <a:p>
+            <a:pPr lvl="0" indent="0" marL="1270000">
+              <a:buNone/>
+            </a:pPr>
             <a:r>
               <a:rPr sz="2000" b="1"/>
-              <a:t>before</a:t>
-            </a:r>
-            <a:r>
-              <a:rPr sz="2000"/>
-              <a:t> collecting.</a:t>
+              <a:t>Agree on the rules or methods before collecting…..</a:t>
             </a:r>
           </a:p>
         </p:txBody>
@@ -3964,74 +3970,70 @@
           <a:bodyPr/>
           <a:lstStyle/>
           <a:p>
-            <a:pPr lvl="0" indent="0" marL="0">
-              <a:buNone/>
-            </a:pPr>
+            <a:pPr lvl="0"/>
             <a:r>
               <a:rPr b="1"/>
               <a:t>What can we measure?</a:t>
             </a:r>
           </a:p>
           <a:p>
-            <a:pPr lvl="0"/>
+            <a:pPr lvl="1"/>
             <a:r>
               <a:rPr/>
               <a:t>mass (grams)</a:t>
             </a:r>
           </a:p>
           <a:p>
-            <a:pPr lvl="0"/>
+            <a:pPr lvl="1"/>
             <a:r>
               <a:rPr/>
               <a:t>length (mm or cm)</a:t>
             </a:r>
           </a:p>
           <a:p>
-            <a:pPr lvl="0"/>
+            <a:pPr lvl="1"/>
             <a:r>
               <a:rPr/>
               <a:t>width (mm or cm)</a:t>
             </a:r>
           </a:p>
           <a:p>
-            <a:pPr lvl="0"/>
+            <a:pPr lvl="1"/>
             <a:r>
               <a:rPr/>
               <a:t>surface area (cm²) — how?</a:t>
             </a:r>
           </a:p>
           <a:p>
-            <a:pPr lvl="0"/>
+            <a:pPr lvl="1"/>
             <a:r>
               <a:rPr/>
               <a:t>others?</a:t>
             </a:r>
           </a:p>
           <a:p>
-            <a:pPr lvl="0" indent="0" marL="0">
-              <a:buNone/>
-            </a:pPr>
+            <a:pPr lvl="0"/>
             <a:r>
               <a:rPr b="1"/>
               <a:t>Decisions to make as a group:</a:t>
             </a:r>
           </a:p>
           <a:p>
-            <a:pPr lvl="0"/>
+            <a:pPr lvl="1"/>
             <a:r>
               <a:rPr/>
               <a:t>What units?</a:t>
             </a:r>
           </a:p>
           <a:p>
-            <a:pPr lvl="0"/>
-            <a:r>
-              <a:rPr/>
-              <a:t>What abbreviations?</a:t>
-            </a:r>
-          </a:p>
-          <a:p>
-            <a:pPr lvl="0"/>
+            <a:pPr lvl="1"/>
+            <a:r>
+              <a:rPr/>
+              <a:t>What abbreviations or vocabulary for the variables?</a:t>
+            </a:r>
+          </a:p>
+          <a:p>
+            <a:pPr lvl="1"/>
             <a:r>
               <a:rPr/>
               <a:t>What if a leaf is damaged?</a:t>
@@ -4072,9 +4074,7 @@
             </a:r>
           </a:p>
           <a:p>
-            <a:pPr lvl="0" indent="0" marL="1270000">
-              <a:buNone/>
-            </a:pPr>
+            <a:pPr lvl="0"/>
             <a:r>
               <a:rPr sz="2000" b="1"/>
               <a:t>Metadata</a:t>
@@ -4093,18 +4093,14 @@
             </a:r>
           </a:p>
           <a:p>
-            <a:pPr lvl="0" indent="0" marL="1270000">
-              <a:buNone/>
-            </a:pPr>
+            <a:pPr lvl="0"/>
             <a:r>
               <a:rPr sz="2000"/>
               <a:t>Who collected it? When? Where? With what instrument? Under what conditions?</a:t>
             </a:r>
           </a:p>
           <a:p>
-            <a:pPr lvl="0" indent="0" marL="1270000">
-              <a:buNone/>
-            </a:pPr>
+            <a:pPr lvl="0"/>
             <a:r>
               <a:rPr sz="2000"/>
               <a:t>Without metadata, data are nearly useless to anyone else — including future you.</a:t>
@@ -4298,7 +4294,7 @@
               <a:rPr sz="2000">
                 <a:latin typeface="Courier"/>
               </a:rPr>
-              <a:t>Leaf Mass (g)</a:t>
+              <a:t>Leaf Mass (g) - why???</a:t>
             </a:r>
           </a:p>
           <a:p>
@@ -4307,7 +4303,7 @@
             </a:pPr>
             <a:r>
               <a:rPr sz="2000"/>
-              <a:t>Consistent, no spaces, no special characters, units in the name.</a:t>
+              <a:t>Consistent, no spaces, no special characters, units in the name and all lower case - why?????</a:t>
             </a:r>
           </a:p>
         </p:txBody>
@@ -4421,7 +4417,7 @@
             </a:pPr>
             <a:r>
               <a:rPr sz="2000"/>
-              <a:t>Excel is great for a first look. But as datasets grow larger and analyses more complex, we need R. Starting Thursday you will see why.</a:t>
+              <a:t>Excel is great for a first look. But as datasets grow larger and analyses more complex, we need another approach - R.</a:t>
             </a:r>
           </a:p>
         </p:txBody>
@@ -5908,17 +5904,23 @@
               <a:rPr b="1"/>
               <a:t>Example:</a:t>
             </a:r>
-            <a:r>
-              <a:rPr/>
-              <a:t> - “Leaves on the shady side are bigger” — </a:t>
+          </a:p>
+          <a:p>
+            <a:pPr lvl="0"/>
+            <a:r>
+              <a:rPr/>
+              <a:t>“Leaves on the shady side are bigger” </a:t>
             </a:r>
             <a:r>
               <a:rPr b="1"/>
               <a:t>testable</a:t>
             </a:r>
-            <a:r>
-              <a:rPr/>
-              <a:t> - “The forest has a spirit that controls leaf size” — </a:t>
+          </a:p>
+          <a:p>
+            <a:pPr lvl="0"/>
+            <a:r>
+              <a:rPr/>
+              <a:t>“The forest has a spirit that controls leaf size” — </a:t>
             </a:r>
             <a:r>
               <a:rPr b="1"/>
@@ -5978,7 +5980,7 @@
             </a:pPr>
             <a:r>
               <a:rPr sz="2000"/>
-              <a:t>A good hypothesis is one you could prove false with the right data.</a:t>
+              <a:t>A good hypothesis is one you could prove false.</a:t>
             </a:r>
           </a:p>
         </p:txBody>
@@ -6121,7 +6123,7 @@
             </a:pPr>
             <a:r>
               <a:rPr sz="2000"/>
-              <a:t>We are going to go outside, collect leaves, and build our first dataset today. That dataset will follow us for the first half of the course.</a:t>
+              <a:t>We are going to go outside, collect leaves, and build our first dataset today. That dataset will follow us for the first part of the course.</a:t>
             </a:r>
           </a:p>
         </p:txBody>
@@ -6210,7 +6212,7 @@
             <a:pPr lvl="0"/>
             <a:r>
               <a:rPr/>
-              <a:t>Suggestion: leaf mass and surface area from the </a:t>
+              <a:t>Suggestion: leaf mass, width, length, and surface area from the </a:t>
             </a:r>
             <a:r>
               <a:rPr b="1"/>
@@ -6229,36 +6231,28 @@
             </a:r>
           </a:p>
           <a:p>
-            <a:pPr lvl="0" indent="0" marL="0">
-              <a:buNone/>
-            </a:pPr>
+            <a:pPr lvl="0"/>
             <a:r>
               <a:rPr b="1"/>
               <a:t>The null hypothesis (H₀):</a:t>
             </a:r>
           </a:p>
           <a:p>
-            <a:pPr lvl="0" indent="0" marL="0">
-              <a:buNone/>
-            </a:pPr>
+            <a:pPr lvl="1"/>
             <a:r>
               <a:rPr i="1"/>
               <a:t>There is no difference in leaf size or shape between the two sides of a tree.</a:t>
             </a:r>
           </a:p>
           <a:p>
-            <a:pPr lvl="0" indent="0" marL="0">
-              <a:buNone/>
-            </a:pPr>
+            <a:pPr lvl="0"/>
             <a:r>
               <a:rPr b="1"/>
               <a:t>The alternate hypothesis (Hₐ):</a:t>
             </a:r>
           </a:p>
           <a:p>
-            <a:pPr lvl="0" indent="0" marL="0">
-              <a:buNone/>
-            </a:pPr>
+            <a:pPr lvl="1"/>
             <a:r>
               <a:rPr i="1"/>
               <a:t>Leaf size differs between the sunny and shady sides.</a:t>
@@ -6400,7 +6394,7 @@
             </a:r>
           </a:p>
           <a:p>
-            <a:pPr lvl="0"/>
+            <a:pPr lvl="1"/>
             <a:r>
               <a:rPr b="1"/>
               <a:t>Predict:</a:t>
@@ -6411,16 +6405,14 @@
             </a:r>
           </a:p>
           <a:p>
-            <a:pPr lvl="1" indent="0" marL="342900">
-              <a:buNone/>
-            </a:pPr>
+            <a:pPr lvl="2"/>
             <a:r>
               <a:rPr i="1"/>
               <a:t>Your prediction:</a:t>
             </a:r>
           </a:p>
           <a:p>
-            <a:pPr lvl="0"/>
+            <a:pPr lvl="1"/>
             <a:r>
               <a:rPr b="1"/>
               <a:t>Hypothesize:</a:t>
@@ -6431,21 +6423,17 @@
             </a:r>
           </a:p>
           <a:p>
-            <a:pPr lvl="1" indent="0" marL="342900">
-              <a:buNone/>
-            </a:pPr>
+            <a:pPr lvl="2"/>
             <a:r>
               <a:rPr i="1"/>
-              <a:t>Your null hypothesis:</a:t>
-            </a:r>
-          </a:p>
-          <a:p>
-            <a:pPr lvl="1" indent="0" marL="342900">
-              <a:buNone/>
-            </a:pPr>
+              <a:t>Your null hypothesis: ____________________________</a:t>
+            </a:r>
+          </a:p>
+          <a:p>
+            <a:pPr lvl="2"/>
             <a:r>
               <a:rPr i="1"/>
-              <a:t>Your alternate hypothesis:</a:t>
+              <a:t>Your alternate hypothesis: ____________________________</a:t>
             </a:r>
           </a:p>
           <a:p>
@@ -6467,9 +6455,7 @@
             </a:r>
           </a:p>
           <a:p>
-            <a:pPr lvl="0" indent="0" marL="1270000">
-              <a:buNone/>
-            </a:pPr>
+            <a:pPr lvl="0"/>
             <a:r>
               <a:rPr sz="2000"/>
               <a:t>A </a:t>
@@ -6480,7 +6466,14 @@
             </a:r>
             <a:r>
               <a:rPr sz="2000"/>
-              <a:t> says what you think will happen. A </a:t>
+              <a:t> says what you think will happen and usually has a direction.</a:t>
+            </a:r>
+          </a:p>
+          <a:p>
+            <a:pPr lvl="0"/>
+            <a:r>
+              <a:rPr sz="2000"/>
+              <a:t>A </a:t>
             </a:r>
             <a:r>
               <a:rPr sz="2000" b="1"/>

</xml_diff>